<commit_message>
fix: split overall insights into 2 pages, remove all lines
</commit_message>
<xml_diff>
--- a/docs/digest-en.pptx
+++ b/docs/digest-en.pptx
@@ -19,9 +19,10 @@
     <p:sldId id="267" r:id="rId13"/>
     <p:sldId id="268" r:id="rId14"/>
     <p:sldId id="269" r:id="rId15"/>
+    <p:sldId id="270" r:id="rId16"/>
   </p:sldIdLst>
   <p:notesMasterIdLst>
-    <p:notesMasterId r:id="rId16"/>
+    <p:notesMasterId r:id="rId17"/>
   </p:notesMasterIdLst>
   <p:sldSz cx="12192000" cy="6858000"/>
   <p:notesSz cx="6858000" cy="12192000"/>
@@ -979,6 +980,94 @@
             <a:fld id="{F7021451-1387-4CA6-816F-3879F97B5CBC}" type="slidenum">
               <a:rPr lang="en-US"/>
               <a:t>14</a:t>
+            </a:fld>
+            <a:endParaRPr lang="en-US"/>
+          </a:p>
+        </p:txBody>
+      </p:sp>
+    </p:spTree>
+    <p:extLst>
+      <p:ext uri="{BB962C8B-B14F-4D97-AF65-F5344CB8AC3E}">
+        <p14:creationId xmlns:p14="http://schemas.microsoft.com/office/powerpoint/2010/main" val="1024086991"/>
+      </p:ext>
+    </p:extLst>
+  </p:cSld>
+  <p:clrMapOvr>
+    <a:masterClrMapping/>
+  </p:clrMapOvr>
+</p:notes>
+</file>
+
+<file path=ppt/notesSlides/notesSlide15.xml><?xml version="1.0" encoding="utf-8"?>
+<p:notes xmlns:a="http://schemas.openxmlformats.org/drawingml/2006/main" xmlns:r="http://schemas.openxmlformats.org/officeDocument/2006/relationships" xmlns:p="http://schemas.openxmlformats.org/presentationml/2006/main">
+  <p:cSld>
+    <p:spTree>
+      <p:nvGrpSpPr>
+        <p:cNvPr id="1" name=""/>
+        <p:cNvGrpSpPr/>
+        <p:nvPr/>
+      </p:nvGrpSpPr>
+      <p:grpSpPr>
+        <a:xfrm>
+          <a:off x="0" y="0"/>
+          <a:ext cx="0" cy="0"/>
+          <a:chOff x="0" y="0"/>
+          <a:chExt cx="0" cy="0"/>
+        </a:xfrm>
+      </p:grpSpPr>
+      <p:sp>
+        <p:nvSpPr>
+          <p:cNvPr id="2" name="Slide Image Placeholder 1"/>
+          <p:cNvSpPr>
+            <a:spLocks noGrp="1" noRot="1" noChangeAspect="1"/>
+          </p:cNvSpPr>
+          <p:nvPr>
+            <p:ph type="sldImg"/>
+          </p:nvPr>
+        </p:nvSpPr>
+        <p:spPr/>
+      </p:sp>
+      <p:sp>
+        <p:nvSpPr>
+          <p:cNvPr id="3" name="Notes Placeholder 2"/>
+          <p:cNvSpPr>
+            <a:spLocks noGrp="1"/>
+          </p:cNvSpPr>
+          <p:nvPr>
+            <p:ph type="body" idx="1"/>
+          </p:nvPr>
+        </p:nvSpPr>
+        <p:spPr/>
+        <p:txBody>
+          <a:bodyPr/>
+          <a:lstStyle/>
+          <a:p>
+            <a:r>
+              <a:rPr lang="en-US" dirty="0"/>
+              <a:t/>
+            </a:r>
+            <a:endParaRPr lang="en-US" dirty="0"/>
+          </a:p>
+        </p:txBody>
+      </p:sp>
+      <p:sp>
+        <p:nvSpPr>
+          <p:cNvPr id="4" name="Slide Number Placeholder 3"/>
+          <p:cNvSpPr>
+            <a:spLocks noGrp="1"/>
+          </p:cNvSpPr>
+          <p:nvPr>
+            <p:ph type="sldNum" sz="quarter" idx="10"/>
+          </p:nvPr>
+        </p:nvSpPr>
+        <p:spPr/>
+        <p:txBody>
+          <a:bodyPr/>
+          <a:lstStyle/>
+          <a:p>
+            <a:fld id="{F7021451-1387-4CA6-816F-3879F97B5CBC}" type="slidenum">
+              <a:rPr lang="en-US"/>
+              <a:t>15</a:t>
             </a:fld>
             <a:endParaRPr lang="en-US"/>
           </a:p>
@@ -2450,7 +2539,7 @@
                 <a:ea typeface="Arial" pitchFamily="34" charset="-122"/>
                 <a:cs typeface="Arial" pitchFamily="34" charset="-120"/>
               </a:rPr>
-              <a:t>Combination of TACE and PD-1 inhibitors</a:t>
+              <a:t>Combination therapy for unresectable HCC</a:t>
             </a:r>
             <a:endParaRPr lang="en-US" sz="1800" dirty="0"/>
           </a:p>
@@ -2471,7 +2560,7 @@
                 <a:ea typeface="Arial" pitchFamily="34" charset="-122"/>
                 <a:cs typeface="Arial" pitchFamily="34" charset="-120"/>
               </a:rPr>
-              <a:t>Phase 2 trial for uHCC patients</a:t>
+              <a:t>Transarterial chemoembolization (TACE) used</a:t>
             </a:r>
             <a:endParaRPr lang="en-US" sz="1800" dirty="0"/>
           </a:p>
@@ -2492,7 +2581,49 @@
                 <a:ea typeface="Arial" pitchFamily="34" charset="-122"/>
                 <a:cs typeface="Arial" pitchFamily="34" charset="-120"/>
               </a:rPr>
-              <a:t>Evaluated efficacy compared to TACE alone</a:t>
+              <a:t>PD-1 inhibitors enhance treatment efficacy</a:t>
+            </a:r>
+            <a:endParaRPr lang="en-US" sz="1800" dirty="0"/>
+          </a:p>
+          <a:p>
+            <a:pPr marL="342900" indent="-342900">
+              <a:spcAft>
+                <a:spcPts val="800"/>
+              </a:spcAft>
+              <a:buSzPct val="100000"/>
+              <a:buChar char="•"/>
+            </a:pPr>
+            <a:r>
+              <a:rPr lang="en-US" sz="1800" dirty="0">
+                <a:solidFill>
+                  <a:srgbClr val="333333"/>
+                </a:solidFill>
+                <a:latin typeface="Arial" pitchFamily="34" charset="0"/>
+                <a:ea typeface="Arial" pitchFamily="34" charset="-122"/>
+                <a:cs typeface="Arial" pitchFamily="34" charset="-120"/>
+              </a:rPr>
+              <a:t>Phase 2 trial demonstrates promising results</a:t>
+            </a:r>
+            <a:endParaRPr lang="en-US" sz="1800" dirty="0"/>
+          </a:p>
+          <a:p>
+            <a:pPr marL="342900" indent="-342900">
+              <a:spcAft>
+                <a:spcPts val="800"/>
+              </a:spcAft>
+              <a:buSzPct val="100000"/>
+              <a:buChar char="•"/>
+            </a:pPr>
+            <a:r>
+              <a:rPr lang="en-US" sz="1800" dirty="0">
+                <a:solidFill>
+                  <a:srgbClr val="333333"/>
+                </a:solidFill>
+                <a:latin typeface="Arial" pitchFamily="34" charset="0"/>
+                <a:ea typeface="Arial" pitchFamily="34" charset="-122"/>
+                <a:cs typeface="Arial" pitchFamily="34" charset="-120"/>
+              </a:rPr>
+              <a:t>Potential for conversion to resectable disease</a:t>
             </a:r>
             <a:endParaRPr lang="en-US" sz="1800" dirty="0"/>
           </a:p>
@@ -2771,7 +2902,7 @@
                 <a:ea typeface="Arial" pitchFamily="34" charset="-122"/>
                 <a:cs typeface="Arial" pitchFamily="34" charset="-120"/>
               </a:rPr>
-              <a:t>Atez+Bev shows 25% ORR in HCC.</a:t>
+              <a:t>Atez+Bev shows efficacy after Dur+Tre</a:t>
             </a:r>
             <a:endParaRPr lang="en-US" sz="1800" dirty="0"/>
           </a:p>
@@ -2792,7 +2923,7 @@
                 <a:ea typeface="Arial" pitchFamily="34" charset="-122"/>
                 <a:cs typeface="Arial" pitchFamily="34" charset="-120"/>
               </a:rPr>
-              <a:t>75% DCR indicates favorable disease control.</a:t>
+              <a:t>ORR 25% and DCR 75% observed</a:t>
             </a:r>
             <a:endParaRPr lang="en-US" sz="1800" dirty="0"/>
           </a:p>
@@ -2813,7 +2944,7 @@
                 <a:ea typeface="Arial" pitchFamily="34" charset="-122"/>
                 <a:cs typeface="Arial" pitchFamily="34" charset="-120"/>
               </a:rPr>
-              <a:t>Adverse events differ between regimens.</a:t>
+              <a:t>Safety profile varies between regimens</a:t>
             </a:r>
             <a:endParaRPr lang="en-US" sz="1800" dirty="0"/>
           </a:p>
@@ -2834,7 +2965,7 @@
                 <a:ea typeface="Arial" pitchFamily="34" charset="-122"/>
                 <a:cs typeface="Arial" pitchFamily="34" charset="-120"/>
               </a:rPr>
-              <a:t>Prior Dur+Tre may enhance immune response.</a:t>
+              <a:t>Prior Dur+Tre may enhance immune response</a:t>
             </a:r>
             <a:endParaRPr lang="en-US" sz="1800" dirty="0"/>
           </a:p>
@@ -2855,7 +2986,7 @@
                 <a:ea typeface="Arial" pitchFamily="34" charset="-122"/>
                 <a:cs typeface="Arial" pitchFamily="34" charset="-120"/>
               </a:rPr>
-              <a:t>Sequential treatment is a viable option.</a:t>
+              <a:t>Common adverse events include pruritus</a:t>
             </a:r>
             <a:endParaRPr lang="en-US" sz="1800" dirty="0"/>
           </a:p>
@@ -3155,7 +3286,7 @@
                 <a:ea typeface="Arial" pitchFamily="34" charset="-122"/>
                 <a:cs typeface="Arial" pitchFamily="34" charset="-120"/>
               </a:rPr>
-              <a:t>EBRT shows different outcomes compared to local ablation.</a:t>
+              <a:t>EBRT compared to local ablation for HCC.</a:t>
             </a:r>
             <a:endParaRPr lang="en-US" sz="1800" dirty="0"/>
           </a:p>
@@ -3176,7 +3307,7 @@
                 <a:ea typeface="Arial" pitchFamily="34" charset="-122"/>
                 <a:cs typeface="Arial" pitchFamily="34" charset="-120"/>
               </a:rPr>
-              <a:t>Meta-analysis evaluates local progression-free survival rates.</a:t>
+              <a:t>Meta-analysis shows local progression-free survival benefits.</a:t>
             </a:r>
             <a:endParaRPr lang="en-US" sz="1800" dirty="0"/>
           </a:p>
@@ -3313,14 +3444,14 @@
           <a:ln/>
         </p:spPr>
         <p:txBody>
-          <a:bodyPr wrap="square" rtlCol="0" anchor="ctr"/>
-          <a:lstStyle/>
-          <a:p>
-            <a:pPr indent="0" marL="0">
-              <a:buNone/>
-            </a:pPr>
-            <a:r>
-              <a:rPr lang="en-US" sz="3000" b="1" dirty="0">
+          <a:bodyPr wrap="square" lIns="0" tIns="0" rIns="0" bIns="0" rtlCol="0" anchor="ctr"/>
+          <a:lstStyle/>
+          <a:p>
+            <a:pPr indent="0" marL="0">
+              <a:buNone/>
+            </a:pPr>
+            <a:r>
+              <a:rPr lang="en-US" sz="2400" b="1" dirty="0">
                 <a:solidFill>
                   <a:srgbClr val="FFFFFF"/>
                 </a:solidFill>
@@ -3328,26 +3459,9 @@
                 <a:ea typeface="Arial" pitchFamily="34" charset="-122"/>
                 <a:cs typeface="Arial" pitchFamily="34" charset="-120"/>
               </a:rPr>
-              <a:t>Overall Insights</a:t>
-            </a:r>
-            <a:endParaRPr lang="en-US" sz="3000" dirty="0"/>
-          </a:p>
-          <a:p>
-            <a:pPr indent="0" marL="0">
-              <a:buNone/>
-            </a:pPr>
-            <a:r>
-              <a:rPr lang="en-US" sz="3000" b="1" dirty="0">
-                <a:solidFill>
-                  <a:srgbClr val="FFFFFF"/>
-                </a:solidFill>
-                <a:latin typeface="Arial" pitchFamily="34" charset="0"/>
-                <a:ea typeface="Arial" pitchFamily="34" charset="-122"/>
-                <a:cs typeface="Arial" pitchFamily="34" charset="-120"/>
-              </a:rPr>
-              <a:t>&amp; Future Directions</a:t>
-            </a:r>
-            <a:endParaRPr lang="en-US" sz="3000" dirty="0"/>
+              <a:t>Overall Insights (1/2)</a:t>
+            </a:r>
+            <a:endParaRPr lang="en-US" sz="2400" dirty="0"/>
           </a:p>
         </p:txBody>
       </p:sp>
@@ -3359,7 +3473,7 @@
         </p:nvSpPr>
         <p:spPr>
           <a:xfrm>
-            <a:off x="731520" y="2560320"/>
+            <a:off x="731520" y="1463040"/>
             <a:ext cx="10515600" cy="0"/>
           </a:xfrm>
           <a:prstGeom prst="rect">
@@ -3374,7 +3488,7 @@
           <a:p>
             <a:pPr indent="0" marL="0">
               <a:lnSpc>
-                <a:spcPct val="160000"/>
+                <a:spcPct val="150000"/>
               </a:lnSpc>
               <a:buNone/>
             </a:pPr>
@@ -3391,7 +3505,7 @@
           <a:p>
             <a:pPr indent="0" marL="0">
               <a:lnSpc>
-                <a:spcPct val="160000"/>
+                <a:spcPct val="150000"/>
               </a:lnSpc>
               <a:buNone/>
             </a:pPr>
@@ -3400,7 +3514,7 @@
           <a:p>
             <a:pPr indent="0" marL="0">
               <a:lnSpc>
-                <a:spcPct val="160000"/>
+                <a:spcPct val="150000"/>
               </a:lnSpc>
               <a:buNone/>
             </a:pPr>
@@ -3417,7 +3531,7 @@
           <a:p>
             <a:pPr indent="0" marL="0">
               <a:lnSpc>
-                <a:spcPct val="160000"/>
+                <a:spcPct val="150000"/>
               </a:lnSpc>
               <a:buNone/>
             </a:pPr>
@@ -3434,7 +3548,7 @@
           <a:p>
             <a:pPr indent="0" marL="0">
               <a:lnSpc>
-                <a:spcPct val="160000"/>
+                <a:spcPct val="150000"/>
               </a:lnSpc>
               <a:buNone/>
             </a:pPr>
@@ -3444,14 +3558,14 @@
                   <a:srgbClr val="FFFFFF"/>
                 </a:solidFill>
               </a:rPr>
-              <a:t>   免疫治療在晚期肝細胞癌（HCC）中顯示出顯著的療效，尤其在早期階段的應用仍需進一步探索。  </a:t>
+              <a:t>   免疫治療在晚期肝細胞癌（HCC）中的應用顯著改善了治療選擇，但在早期階段的最佳使用仍需進一步探索。  </a:t>
             </a:r>
             <a:endParaRPr lang="en-US" sz="1200" dirty="0"/>
           </a:p>
           <a:p>
             <a:pPr indent="0" marL="0">
               <a:lnSpc>
-                <a:spcPct val="160000"/>
+                <a:spcPct val="150000"/>
               </a:lnSpc>
               <a:buNone/>
             </a:pPr>
@@ -3461,14 +3575,14 @@
                   <a:srgbClr val="FFFFFF"/>
                 </a:solidFill>
               </a:rPr>
-              <a:t>   Immunotherapy has shown significant efficacy in advanced hepatocellular carcinoma (HCC), particularly its application in earlier stages remains to be further explored.</a:t>
+              <a:t>   Immunotherapy has significantly improved treatment options for advanced hepatocellular carcinoma (HCC), yet optimal usage in earlier stages remains to be fully explored.</a:t>
             </a:r>
             <a:endParaRPr lang="en-US" sz="1200" dirty="0"/>
           </a:p>
           <a:p>
             <a:pPr indent="0" marL="0">
               <a:lnSpc>
-                <a:spcPct val="160000"/>
+                <a:spcPct val="150000"/>
               </a:lnSpc>
               <a:buNone/>
             </a:pPr>
@@ -3477,7 +3591,7 @@
           <a:p>
             <a:pPr indent="0" marL="0">
               <a:lnSpc>
-                <a:spcPct val="160000"/>
+                <a:spcPct val="150000"/>
               </a:lnSpc>
               <a:buNone/>
             </a:pPr>
@@ -3494,7 +3608,7 @@
           <a:p>
             <a:pPr indent="0" marL="0">
               <a:lnSpc>
-                <a:spcPct val="160000"/>
+                <a:spcPct val="150000"/>
               </a:lnSpc>
               <a:buNone/>
             </a:pPr>
@@ -3511,7 +3625,7 @@
           <a:p>
             <a:pPr indent="0" marL="0">
               <a:lnSpc>
-                <a:spcPct val="160000"/>
+                <a:spcPct val="150000"/>
               </a:lnSpc>
               <a:buNone/>
             </a:pPr>
@@ -3521,14 +3635,14 @@
                   <a:srgbClr val="FFFFFF"/>
                 </a:solidFill>
               </a:rPr>
-              <a:t>   新的療法如新輔助立體定向放射治療結合免疫治療能有效重塑HCC的腫瘤微環境，增強治療反應。  </a:t>
+              <a:t>   新的研究顯示，術前立體定向放射治療結合免疫治療能有效改變HCC的腫瘤微環境，促進治療效果。  </a:t>
             </a:r>
             <a:endParaRPr lang="en-US" sz="1200" dirty="0"/>
           </a:p>
           <a:p>
             <a:pPr indent="0" marL="0">
               <a:lnSpc>
-                <a:spcPct val="160000"/>
+                <a:spcPct val="150000"/>
               </a:lnSpc>
               <a:buNone/>
             </a:pPr>
@@ -3538,14 +3652,14 @@
                   <a:srgbClr val="FFFFFF"/>
                 </a:solidFill>
               </a:rPr>
-              <a:t>   Novel therapies such as neoadjuvant stereotactic body radiation therapy combined with immunotherapy can effectively remodel the HCC tumor microenvironment, enhancing treatment responses.</a:t>
+              <a:t>   Recent studies indicate that neoadjuvant stereotactic body radiation therapy combined with immunotherapy can effectively remodel the tumor microenvironment in HCC, enhancing treatment efficacy.</a:t>
             </a:r>
             <a:endParaRPr lang="en-US" sz="1200" dirty="0"/>
           </a:p>
           <a:p>
             <a:pPr indent="0" marL="0">
               <a:lnSpc>
-                <a:spcPct val="160000"/>
+                <a:spcPct val="150000"/>
               </a:lnSpc>
               <a:buNone/>
             </a:pPr>
@@ -3554,7 +3668,7 @@
           <a:p>
             <a:pPr indent="0" marL="0">
               <a:lnSpc>
-                <a:spcPct val="160000"/>
+                <a:spcPct val="150000"/>
               </a:lnSpc>
               <a:buNone/>
             </a:pPr>
@@ -3571,7 +3685,7 @@
           <a:p>
             <a:pPr indent="0" marL="0">
               <a:lnSpc>
-                <a:spcPct val="160000"/>
+                <a:spcPct val="150000"/>
               </a:lnSpc>
               <a:buNone/>
             </a:pPr>
@@ -3588,7 +3702,7 @@
           <a:p>
             <a:pPr indent="0" marL="0">
               <a:lnSpc>
-                <a:spcPct val="160000"/>
+                <a:spcPct val="150000"/>
               </a:lnSpc>
               <a:buNone/>
             </a:pPr>
@@ -3598,14 +3712,14 @@
                   <a:srgbClr val="FFFFFF"/>
                 </a:solidFill>
               </a:rPr>
-              <a:t>   癌症相關成纖維細胞（CAFs）在HCC中促進免疫抑制，揭示了其作為潛在治療靶點的重要性。  </a:t>
+              <a:t>   癌症相關成纖維細胞（CAFs）在HCC中推動免疫抑制，理解其代謝調控對開發新療法至關重要。  </a:t>
             </a:r>
             <a:endParaRPr lang="en-US" sz="1200" dirty="0"/>
           </a:p>
           <a:p>
             <a:pPr indent="0" marL="0">
               <a:lnSpc>
-                <a:spcPct val="160000"/>
+                <a:spcPct val="150000"/>
               </a:lnSpc>
               <a:buNone/>
             </a:pPr>
@@ -3615,14 +3729,14 @@
                   <a:srgbClr val="FFFFFF"/>
                 </a:solidFill>
               </a:rPr>
-              <a:t>   Cancer-associated fibroblasts (CAFs) promote immunosuppression in HCC, highlighting their importance as potential therapeutic targets.</a:t>
+              <a:t>   Cancer-associated fibroblasts (CAFs) drive immunosuppression in HCC, and understanding their metabolic regulation is crucial for developing new therapeutic strategies.</a:t>
             </a:r>
             <a:endParaRPr lang="en-US" sz="1200" dirty="0"/>
           </a:p>
           <a:p>
             <a:pPr indent="0" marL="0">
               <a:lnSpc>
-                <a:spcPct val="160000"/>
+                <a:spcPct val="150000"/>
               </a:lnSpc>
               <a:buNone/>
             </a:pPr>
@@ -3631,7 +3745,7 @@
           <a:p>
             <a:pPr indent="0" marL="0">
               <a:lnSpc>
-                <a:spcPct val="160000"/>
+                <a:spcPct val="150000"/>
               </a:lnSpc>
               <a:buNone/>
             </a:pPr>
@@ -3648,7 +3762,7 @@
           <a:p>
             <a:pPr indent="0" marL="0">
               <a:lnSpc>
-                <a:spcPct val="160000"/>
+                <a:spcPct val="150000"/>
               </a:lnSpc>
               <a:buNone/>
             </a:pPr>
@@ -3665,7 +3779,7 @@
           <a:p>
             <a:pPr indent="0" marL="0">
               <a:lnSpc>
-                <a:spcPct val="160000"/>
+                <a:spcPct val="150000"/>
               </a:lnSpc>
               <a:buNone/>
             </a:pPr>
@@ -3675,14 +3789,14 @@
                   <a:srgbClr val="FFFFFF"/>
                 </a:solidFill>
               </a:rPr>
-              <a:t>   雖然手術切除對早期HCC有效，但術後復發仍是主要的臨床挑戰，需深入研究其機制。  </a:t>
+              <a:t>   雖然外科切除是早期HCC的有效干預措施，但術後復發仍然是主要的臨床挑戰。  </a:t>
             </a:r>
             <a:endParaRPr lang="en-US" sz="1200" dirty="0"/>
           </a:p>
           <a:p>
             <a:pPr indent="0" marL="0">
               <a:lnSpc>
-                <a:spcPct val="160000"/>
+                <a:spcPct val="150000"/>
               </a:lnSpc>
               <a:buNone/>
             </a:pPr>
@@ -3692,14 +3806,14 @@
                   <a:srgbClr val="FFFFFF"/>
                 </a:solidFill>
               </a:rPr>
-              <a:t>   While surgical resection is effective for early-stage HCC, postoperative recurrence remains a major clinical challenge that requires deeper investigation into its mechanisms.</a:t>
+              <a:t>   While surgical resection is an effective intervention for early-stage HCC, postoperative recurrence remains a significant clinical challenge.</a:t>
             </a:r>
             <a:endParaRPr lang="en-US" sz="1200" dirty="0"/>
           </a:p>
           <a:p>
             <a:pPr indent="0" marL="0">
               <a:lnSpc>
-                <a:spcPct val="160000"/>
+                <a:spcPct val="150000"/>
               </a:lnSpc>
               <a:buNone/>
             </a:pPr>
@@ -3708,7 +3822,7 @@
           <a:p>
             <a:pPr indent="0" marL="0">
               <a:lnSpc>
-                <a:spcPct val="160000"/>
+                <a:spcPct val="150000"/>
               </a:lnSpc>
               <a:buNone/>
             </a:pPr>
@@ -3718,14 +3832,14 @@
                   <a:srgbClr val="FFFFFF"/>
                 </a:solidFill>
               </a:rPr>
-              <a:t>5. **多模態治療策略的必要性**  </a:t>
+              <a:t>5. **多模式治療的前景**  </a:t>
             </a:r>
             <a:endParaRPr lang="en-US" sz="1200" dirty="0"/>
           </a:p>
           <a:p>
             <a:pPr indent="0" marL="0">
               <a:lnSpc>
-                <a:spcPct val="160000"/>
+                <a:spcPct val="150000"/>
               </a:lnSpc>
               <a:buNone/>
             </a:pPr>
@@ -3735,14 +3849,14 @@
                   <a:srgbClr val="FFFFFF"/>
                 </a:solidFill>
               </a:rPr>
-              <a:t>   **Necessity of Multimodal Treatment Strategies**  </a:t>
+              <a:t>   **Prospects of Multimodal Therapy**  </a:t>
             </a:r>
             <a:endParaRPr lang="en-US" sz="1200" dirty="0"/>
           </a:p>
           <a:p>
             <a:pPr indent="0" marL="0">
               <a:lnSpc>
-                <a:spcPct val="160000"/>
+                <a:spcPct val="150000"/>
               </a:lnSpc>
               <a:buNone/>
             </a:pPr>
@@ -3752,14 +3866,14 @@
                   <a:srgbClr val="FFFFFF"/>
                 </a:solidFill>
               </a:rPr>
-              <a:t>   對於不可切除的中晚期HCC，結合局部消融、化療和免疫治療的多模態策略顯示出潛在的療效。  </a:t>
+              <a:t>   結合不同治療方法（如TACE、免疫治療和局部消融）可能為不可切除的HCC提供更佳的治療結果。  </a:t>
             </a:r>
             <a:endParaRPr lang="en-US" sz="1200" dirty="0"/>
           </a:p>
           <a:p>
             <a:pPr indent="0" marL="0">
               <a:lnSpc>
-                <a:spcPct val="160000"/>
+                <a:spcPct val="150000"/>
               </a:lnSpc>
               <a:buNone/>
             </a:pPr>
@@ -3769,418 +3883,7 @@
                   <a:srgbClr val="FFFFFF"/>
                 </a:solidFill>
               </a:rPr>
-              <a:t>   For unresectable intermediate-advanced HCC, multimodal strategies combining local ablation, chemotherapy, and immunotherapy show potential efficacy.</a:t>
-            </a:r>
-            <a:endParaRPr lang="en-US" sz="1200" dirty="0"/>
-          </a:p>
-          <a:p>
-            <a:pPr indent="0" marL="0">
-              <a:lnSpc>
-                <a:spcPct val="160000"/>
-              </a:lnSpc>
-              <a:buNone/>
-            </a:pPr>
-            <a:endParaRPr lang="en-US" sz="1200" dirty="0"/>
-          </a:p>
-          <a:p>
-            <a:pPr indent="0" marL="0">
-              <a:lnSpc>
-                <a:spcPct val="160000"/>
-              </a:lnSpc>
-              <a:buNone/>
-            </a:pPr>
-            <a:r>
-              <a:rPr lang="en-US" sz="1200" dirty="0">
-                <a:solidFill>
-                  <a:srgbClr val="FFFFFF"/>
-                </a:solidFill>
-              </a:rPr>
-              <a:t>### 未來研究方向 (Future Research Directions)</a:t>
-            </a:r>
-            <a:endParaRPr lang="en-US" sz="1200" dirty="0"/>
-          </a:p>
-          <a:p>
-            <a:pPr indent="0" marL="0">
-              <a:lnSpc>
-                <a:spcPct val="160000"/>
-              </a:lnSpc>
-              <a:buNone/>
-            </a:pPr>
-            <a:endParaRPr lang="en-US" sz="1200" dirty="0"/>
-          </a:p>
-          <a:p>
-            <a:pPr indent="0" marL="0">
-              <a:lnSpc>
-                <a:spcPct val="160000"/>
-              </a:lnSpc>
-              <a:buNone/>
-            </a:pPr>
-            <a:r>
-              <a:rPr lang="en-US" sz="1200" dirty="0">
-                <a:solidFill>
-                  <a:srgbClr val="FFFFFF"/>
-                </a:solidFill>
-              </a:rPr>
-              <a:t>1. **早期階段免疫治療的最佳化**  </a:t>
-            </a:r>
-            <a:endParaRPr lang="en-US" sz="1200" dirty="0"/>
-          </a:p>
-          <a:p>
-            <a:pPr indent="0" marL="0">
-              <a:lnSpc>
-                <a:spcPct val="160000"/>
-              </a:lnSpc>
-              <a:buNone/>
-            </a:pPr>
-            <a:r>
-              <a:rPr lang="en-US" sz="1200" dirty="0">
-                <a:solidFill>
-                  <a:srgbClr val="FFFFFF"/>
-                </a:solidFill>
-              </a:rPr>
-              <a:t>   **Optimization of Immunotherapy in Early Stages**  </a:t>
-            </a:r>
-            <a:endParaRPr lang="en-US" sz="1200" dirty="0"/>
-          </a:p>
-          <a:p>
-            <a:pPr indent="0" marL="0">
-              <a:lnSpc>
-                <a:spcPct val="160000"/>
-              </a:lnSpc>
-              <a:buNone/>
-            </a:pPr>
-            <a:r>
-              <a:rPr lang="en-US" sz="1200" dirty="0">
-                <a:solidFill>
-                  <a:srgbClr val="FFFFFF"/>
-                </a:solidFill>
-              </a:rPr>
-              <a:t>   需進一步研究如何在早期肝細胞癌中最佳化免疫治療的使用，以提高療效。  </a:t>
-            </a:r>
-            <a:endParaRPr lang="en-US" sz="1200" dirty="0"/>
-          </a:p>
-          <a:p>
-            <a:pPr indent="0" marL="0">
-              <a:lnSpc>
-                <a:spcPct val="160000"/>
-              </a:lnSpc>
-              <a:buNone/>
-            </a:pPr>
-            <a:r>
-              <a:rPr lang="en-US" sz="1200" dirty="0">
-                <a:solidFill>
-                  <a:srgbClr val="FFFFFF"/>
-                </a:solidFill>
-              </a:rPr>
-              <a:t>   Further research is needed to optimize the use of immunotherapy in early-stage hepatocellular carcinoma to enhance efficacy.</a:t>
-            </a:r>
-            <a:endParaRPr lang="en-US" sz="1200" dirty="0"/>
-          </a:p>
-          <a:p>
-            <a:pPr indent="0" marL="0">
-              <a:lnSpc>
-                <a:spcPct val="160000"/>
-              </a:lnSpc>
-              <a:buNone/>
-            </a:pPr>
-            <a:endParaRPr lang="en-US" sz="1200" dirty="0"/>
-          </a:p>
-          <a:p>
-            <a:pPr indent="0" marL="0">
-              <a:lnSpc>
-                <a:spcPct val="160000"/>
-              </a:lnSpc>
-              <a:buNone/>
-            </a:pPr>
-            <a:r>
-              <a:rPr lang="en-US" sz="1200" dirty="0">
-                <a:solidFill>
-                  <a:srgbClr val="FFFFFF"/>
-                </a:solidFill>
-              </a:rPr>
-              <a:t>2. **腫瘤微環境的深入分析**  </a:t>
-            </a:r>
-            <a:endParaRPr lang="en-US" sz="1200" dirty="0"/>
-          </a:p>
-          <a:p>
-            <a:pPr indent="0" marL="0">
-              <a:lnSpc>
-                <a:spcPct val="160000"/>
-              </a:lnSpc>
-              <a:buNone/>
-            </a:pPr>
-            <a:r>
-              <a:rPr lang="en-US" sz="1200" dirty="0">
-                <a:solidFill>
-                  <a:srgbClr val="FFFFFF"/>
-                </a:solidFill>
-              </a:rPr>
-              <a:t>   **In-depth Analysis of Tumor Microenvironment**  </a:t>
-            </a:r>
-            <a:endParaRPr lang="en-US" sz="1200" dirty="0"/>
-          </a:p>
-          <a:p>
-            <a:pPr indent="0" marL="0">
-              <a:lnSpc>
-                <a:spcPct val="160000"/>
-              </a:lnSpc>
-              <a:buNone/>
-            </a:pPr>
-            <a:r>
-              <a:rPr lang="en-US" sz="1200" dirty="0">
-                <a:solidFill>
-                  <a:srgbClr val="FFFFFF"/>
-                </a:solidFill>
-              </a:rPr>
-              <a:t>   對腫瘤微環境的組成及其對免疫反應的影響進行深入研究，以開發新療法。  </a:t>
-            </a:r>
-            <a:endParaRPr lang="en-US" sz="1200" dirty="0"/>
-          </a:p>
-          <a:p>
-            <a:pPr indent="0" marL="0">
-              <a:lnSpc>
-                <a:spcPct val="160000"/>
-              </a:lnSpc>
-              <a:buNone/>
-            </a:pPr>
-            <a:r>
-              <a:rPr lang="en-US" sz="1200" dirty="0">
-                <a:solidFill>
-                  <a:srgbClr val="FFFFFF"/>
-                </a:solidFill>
-              </a:rPr>
-              <a:t>   In-depth studies on the composition of the tumor microenvironment and its impact on immune responses are essential for developing new therapies.</a:t>
-            </a:r>
-            <a:endParaRPr lang="en-US" sz="1200" dirty="0"/>
-          </a:p>
-          <a:p>
-            <a:pPr indent="0" marL="0">
-              <a:lnSpc>
-                <a:spcPct val="160000"/>
-              </a:lnSpc>
-              <a:buNone/>
-            </a:pPr>
-            <a:endParaRPr lang="en-US" sz="1200" dirty="0"/>
-          </a:p>
-          <a:p>
-            <a:pPr indent="0" marL="0">
-              <a:lnSpc>
-                <a:spcPct val="160000"/>
-              </a:lnSpc>
-              <a:buNone/>
-            </a:pPr>
-            <a:r>
-              <a:rPr lang="en-US" sz="1200" dirty="0">
-                <a:solidFill>
-                  <a:srgbClr val="FFFFFF"/>
-                </a:solidFill>
-              </a:rPr>
-              <a:t>3. **癌症相關成纖維細胞的代謝調控**  </a:t>
-            </a:r>
-            <a:endParaRPr lang="en-US" sz="1200" dirty="0"/>
-          </a:p>
-          <a:p>
-            <a:pPr indent="0" marL="0">
-              <a:lnSpc>
-                <a:spcPct val="160000"/>
-              </a:lnSpc>
-              <a:buNone/>
-            </a:pPr>
-            <a:r>
-              <a:rPr lang="en-US" sz="1200" dirty="0">
-                <a:solidFill>
-                  <a:srgbClr val="FFFFFF"/>
-                </a:solidFill>
-              </a:rPr>
-              <a:t>   **Metabolic Regulation of Cancer-Associated Fibroblasts**  </a:t>
-            </a:r>
-            <a:endParaRPr lang="en-US" sz="1200" dirty="0"/>
-          </a:p>
-          <a:p>
-            <a:pPr indent="0" marL="0">
-              <a:lnSpc>
-                <a:spcPct val="160000"/>
-              </a:lnSpc>
-              <a:buNone/>
-            </a:pPr>
-            <a:r>
-              <a:rPr lang="en-US" sz="1200" dirty="0">
-                <a:solidFill>
-                  <a:srgbClr val="FFFFFF"/>
-                </a:solidFill>
-              </a:rPr>
-              <a:t>   探索癌症相關成纖維細胞的代謝調控機制，以尋找新的免疫治療靶點。  </a:t>
-            </a:r>
-            <a:endParaRPr lang="en-US" sz="1200" dirty="0"/>
-          </a:p>
-          <a:p>
-            <a:pPr indent="0" marL="0">
-              <a:lnSpc>
-                <a:spcPct val="160000"/>
-              </a:lnSpc>
-              <a:buNone/>
-            </a:pPr>
-            <a:r>
-              <a:rPr lang="en-US" sz="1200" dirty="0">
-                <a:solidFill>
-                  <a:srgbClr val="FFFFFF"/>
-                </a:solidFill>
-              </a:rPr>
-              <a:t>   Exploring the metabolic regulatory mechanisms of cancer-associated fibroblasts to identify new immunotherapeutic targets is crucial.</a:t>
-            </a:r>
-            <a:endParaRPr lang="en-US" sz="1200" dirty="0"/>
-          </a:p>
-          <a:p>
-            <a:pPr indent="0" marL="0">
-              <a:lnSpc>
-                <a:spcPct val="160000"/>
-              </a:lnSpc>
-              <a:buNone/>
-            </a:pPr>
-            <a:endParaRPr lang="en-US" sz="1200" dirty="0"/>
-          </a:p>
-          <a:p>
-            <a:pPr indent="0" marL="0">
-              <a:lnSpc>
-                <a:spcPct val="160000"/>
-              </a:lnSpc>
-              <a:buNone/>
-            </a:pPr>
-            <a:r>
-              <a:rPr lang="en-US" sz="1200" dirty="0">
-                <a:solidFill>
-                  <a:srgbClr val="FFFFFF"/>
-                </a:solidFill>
-              </a:rPr>
-              <a:t>4. **多模態治療的臨床試驗**  </a:t>
-            </a:r>
-            <a:endParaRPr lang="en-US" sz="1200" dirty="0"/>
-          </a:p>
-          <a:p>
-            <a:pPr indent="0" marL="0">
-              <a:lnSpc>
-                <a:spcPct val="160000"/>
-              </a:lnSpc>
-              <a:buNone/>
-            </a:pPr>
-            <a:r>
-              <a:rPr lang="en-US" sz="1200" dirty="0">
-                <a:solidFill>
-                  <a:srgbClr val="FFFFFF"/>
-                </a:solidFill>
-              </a:rPr>
-              <a:t>   **Clinical Trials on Multimodal Treatments**  </a:t>
-            </a:r>
-            <a:endParaRPr lang="en-US" sz="1200" dirty="0"/>
-          </a:p>
-          <a:p>
-            <a:pPr indent="0" marL="0">
-              <a:lnSpc>
-                <a:spcPct val="160000"/>
-              </a:lnSpc>
-              <a:buNone/>
-            </a:pPr>
-            <a:r>
-              <a:rPr lang="en-US" sz="1200" dirty="0">
-                <a:solidFill>
-                  <a:srgbClr val="FFFFFF"/>
-                </a:solidFill>
-              </a:rPr>
-              <a:t>   設計針對不可切除HCC的多模態治療的臨床試驗，以評估其安全性和有效性。  </a:t>
-            </a:r>
-            <a:endParaRPr lang="en-US" sz="1200" dirty="0"/>
-          </a:p>
-          <a:p>
-            <a:pPr indent="0" marL="0">
-              <a:lnSpc>
-                <a:spcPct val="160000"/>
-              </a:lnSpc>
-              <a:buNone/>
-            </a:pPr>
-            <a:r>
-              <a:rPr lang="en-US" sz="1200" dirty="0">
-                <a:solidFill>
-                  <a:srgbClr val="FFFFFF"/>
-                </a:solidFill>
-              </a:rPr>
-              <a:t>   Designing clinical trials for multimodal treatments targeting unresectable HCC to evaluate their safety and efficacy is essential.</a:t>
-            </a:r>
-            <a:endParaRPr lang="en-US" sz="1200" dirty="0"/>
-          </a:p>
-          <a:p>
-            <a:pPr indent="0" marL="0">
-              <a:lnSpc>
-                <a:spcPct val="160000"/>
-              </a:lnSpc>
-              <a:buNone/>
-            </a:pPr>
-            <a:endParaRPr lang="en-US" sz="1200" dirty="0"/>
-          </a:p>
-          <a:p>
-            <a:pPr indent="0" marL="0">
-              <a:lnSpc>
-                <a:spcPct val="160000"/>
-              </a:lnSpc>
-              <a:buNone/>
-            </a:pPr>
-            <a:r>
-              <a:rPr lang="en-US" sz="1200" dirty="0">
-                <a:solidFill>
-                  <a:srgbClr val="FFFFFF"/>
-                </a:solidFill>
-              </a:rPr>
-              <a:t>5. **個體化治療策略的發展**  </a:t>
-            </a:r>
-            <a:endParaRPr lang="en-US" sz="1200" dirty="0"/>
-          </a:p>
-          <a:p>
-            <a:pPr indent="0" marL="0">
-              <a:lnSpc>
-                <a:spcPct val="160000"/>
-              </a:lnSpc>
-              <a:buNone/>
-            </a:pPr>
-            <a:r>
-              <a:rPr lang="en-US" sz="1200" dirty="0">
-                <a:solidFill>
-                  <a:srgbClr val="FFFFFF"/>
-                </a:solidFill>
-              </a:rPr>
-              <a:t>   **Development of Personalized Treatment Strategies**  </a:t>
-            </a:r>
-            <a:endParaRPr lang="en-US" sz="1200" dirty="0"/>
-          </a:p>
-          <a:p>
-            <a:pPr indent="0" marL="0">
-              <a:lnSpc>
-                <a:spcPct val="160000"/>
-              </a:lnSpc>
-              <a:buNone/>
-            </a:pPr>
-            <a:r>
-              <a:rPr lang="en-US" sz="1200" dirty="0">
-                <a:solidFill>
-                  <a:srgbClr val="FFFFFF"/>
-                </a:solidFill>
-              </a:rPr>
-              <a:t>   基於患者的基因組學和腫瘤特徵，發展個體化的治療策略以提高治療效果。  </a:t>
-            </a:r>
-            <a:endParaRPr lang="en-US" sz="1200" dirty="0"/>
-          </a:p>
-          <a:p>
-            <a:pPr indent="0" marL="0">
-              <a:lnSpc>
-                <a:spcPct val="160000"/>
-              </a:lnSpc>
-              <a:buNone/>
-            </a:pPr>
-            <a:r>
-              <a:rPr lang="en-US" sz="1200" dirty="0">
-                <a:solidFill>
-                  <a:srgbClr val="FFFFFF"/>
-                </a:solidFill>
-              </a:rPr>
-              <a:t>   Developing personalized treatment strategies based on patient genomics and tumor characteristics to improve treatment outcomes is vital.</a:t>
+              <a:t>   Combining various treatment modalities (such as TACE, immunotherapy, and local ablation) may offer better outcomes for unresectable HCC.</a:t>
             </a:r>
             <a:endParaRPr lang="en-US" sz="1200" dirty="0"/>
           </a:p>
@@ -4197,6 +3900,537 @@
 <file path=ppt/slides/slide14.xml><?xml version="1.0" encoding="utf-8"?>
 <p:sld xmlns:a="http://schemas.openxmlformats.org/drawingml/2006/main" xmlns:r="http://schemas.openxmlformats.org/officeDocument/2006/relationships" xmlns:p="http://schemas.openxmlformats.org/presentationml/2006/main">
   <p:cSld name="Slide 14">
+    <p:bg>
+      <p:bgPr>
+        <a:solidFill>
+          <a:srgbClr val="7F1D1D"/>
+        </a:solidFill>
+      </p:bgPr>
+    </p:bg>
+    <p:spTree>
+      <p:nvGrpSpPr>
+        <p:cNvPr id="1" name=""/>
+        <p:cNvGrpSpPr/>
+        <p:nvPr/>
+      </p:nvGrpSpPr>
+      <p:grpSpPr>
+        <a:xfrm>
+          <a:off x="0" y="0"/>
+          <a:ext cx="0" cy="0"/>
+          <a:chOff x="0" y="0"/>
+          <a:chExt cx="0" cy="0"/>
+        </a:xfrm>
+      </p:grpSpPr>
+      <p:sp>
+        <p:nvSpPr>
+          <p:cNvPr id="2" name="Text 0"/>
+          <p:cNvSpPr/>
+          <p:nvPr/>
+        </p:nvSpPr>
+        <p:spPr>
+          <a:xfrm>
+            <a:off x="731520" y="365760"/>
+            <a:ext cx="5486400" cy="0"/>
+          </a:xfrm>
+          <a:prstGeom prst="rect">
+            <a:avLst/>
+          </a:prstGeom>
+          <a:noFill/>
+          <a:ln/>
+        </p:spPr>
+        <p:txBody>
+          <a:bodyPr wrap="square" lIns="0" tIns="0" rIns="0" bIns="0" rtlCol="0" anchor="ctr"/>
+          <a:lstStyle/>
+          <a:p>
+            <a:pPr indent="0" marL="0">
+              <a:buNone/>
+            </a:pPr>
+            <a:r>
+              <a:rPr lang="en-US" sz="900" spc="600" kern="0" dirty="0">
+                <a:solidFill>
+                  <a:srgbClr val="888888"/>
+                </a:solidFill>
+              </a:rPr>
+              <a:t>SYNTHESIS</a:t>
+            </a:r>
+            <a:endParaRPr lang="en-US" sz="900" dirty="0"/>
+          </a:p>
+        </p:txBody>
+      </p:sp>
+      <p:sp>
+        <p:nvSpPr>
+          <p:cNvPr id="3" name="Text 1"/>
+          <p:cNvSpPr/>
+          <p:nvPr/>
+        </p:nvSpPr>
+        <p:spPr>
+          <a:xfrm>
+            <a:off x="731520" y="822960"/>
+            <a:ext cx="10058400" cy="0"/>
+          </a:xfrm>
+          <a:prstGeom prst="rect">
+            <a:avLst/>
+          </a:prstGeom>
+          <a:noFill/>
+          <a:ln/>
+        </p:spPr>
+        <p:txBody>
+          <a:bodyPr wrap="square" lIns="0" tIns="0" rIns="0" bIns="0" rtlCol="0" anchor="ctr"/>
+          <a:lstStyle/>
+          <a:p>
+            <a:pPr indent="0" marL="0">
+              <a:buNone/>
+            </a:pPr>
+            <a:r>
+              <a:rPr lang="en-US" sz="2400" b="1" dirty="0">
+                <a:solidFill>
+                  <a:srgbClr val="FFFFFF"/>
+                </a:solidFill>
+                <a:latin typeface="Arial" pitchFamily="34" charset="0"/>
+                <a:ea typeface="Arial" pitchFamily="34" charset="-122"/>
+                <a:cs typeface="Arial" pitchFamily="34" charset="-120"/>
+              </a:rPr>
+              <a:t>Future Directions (2/2)</a:t>
+            </a:r>
+            <a:endParaRPr lang="en-US" sz="2400" dirty="0"/>
+          </a:p>
+        </p:txBody>
+      </p:sp>
+      <p:sp>
+        <p:nvSpPr>
+          <p:cNvPr id="4" name="Text 2"/>
+          <p:cNvSpPr/>
+          <p:nvPr/>
+        </p:nvSpPr>
+        <p:spPr>
+          <a:xfrm>
+            <a:off x="731520" y="1463040"/>
+            <a:ext cx="10515600" cy="0"/>
+          </a:xfrm>
+          <a:prstGeom prst="rect">
+            <a:avLst/>
+          </a:prstGeom>
+          <a:noFill/>
+          <a:ln/>
+        </p:spPr>
+        <p:txBody>
+          <a:bodyPr wrap="square" rtlCol="0" anchor="ctr"/>
+          <a:lstStyle/>
+          <a:p>
+            <a:pPr indent="0" marL="0">
+              <a:lnSpc>
+                <a:spcPct val="150000"/>
+              </a:lnSpc>
+              <a:buNone/>
+            </a:pPr>
+            <a:r>
+              <a:rPr lang="en-US" sz="1200" dirty="0">
+                <a:solidFill>
+                  <a:srgbClr val="FFFFFF"/>
+                </a:solidFill>
+              </a:rPr>
+              <a:t>### 未來研究方向 (Future Research Directions)</a:t>
+            </a:r>
+            <a:endParaRPr lang="en-US" sz="1200" dirty="0"/>
+          </a:p>
+          <a:p>
+            <a:pPr indent="0" marL="0">
+              <a:lnSpc>
+                <a:spcPct val="150000"/>
+              </a:lnSpc>
+              <a:buNone/>
+            </a:pPr>
+            <a:endParaRPr lang="en-US" sz="1200" dirty="0"/>
+          </a:p>
+          <a:p>
+            <a:pPr indent="0" marL="0">
+              <a:lnSpc>
+                <a:spcPct val="150000"/>
+              </a:lnSpc>
+              <a:buNone/>
+            </a:pPr>
+            <a:r>
+              <a:rPr lang="en-US" sz="1200" dirty="0">
+                <a:solidFill>
+                  <a:srgbClr val="FFFFFF"/>
+                </a:solidFill>
+              </a:rPr>
+              <a:t>1. **早期階段免疫治療的最佳化**  </a:t>
+            </a:r>
+            <a:endParaRPr lang="en-US" sz="1200" dirty="0"/>
+          </a:p>
+          <a:p>
+            <a:pPr indent="0" marL="0">
+              <a:lnSpc>
+                <a:spcPct val="150000"/>
+              </a:lnSpc>
+              <a:buNone/>
+            </a:pPr>
+            <a:r>
+              <a:rPr lang="en-US" sz="1200" dirty="0">
+                <a:solidFill>
+                  <a:srgbClr val="FFFFFF"/>
+                </a:solidFill>
+              </a:rPr>
+              <a:t>   **Optimization of Immunotherapy in Early Stages**  </a:t>
+            </a:r>
+            <a:endParaRPr lang="en-US" sz="1200" dirty="0"/>
+          </a:p>
+          <a:p>
+            <a:pPr indent="0" marL="0">
+              <a:lnSpc>
+                <a:spcPct val="150000"/>
+              </a:lnSpc>
+              <a:buNone/>
+            </a:pPr>
+            <a:r>
+              <a:rPr lang="en-US" sz="1200" dirty="0">
+                <a:solidFill>
+                  <a:srgbClr val="FFFFFF"/>
+                </a:solidFill>
+              </a:rPr>
+              <a:t>   需要進一步研究以確定免疫治療在早期HCC中的最佳使用時機和方式。  </a:t>
+            </a:r>
+            <a:endParaRPr lang="en-US" sz="1200" dirty="0"/>
+          </a:p>
+          <a:p>
+            <a:pPr indent="0" marL="0">
+              <a:lnSpc>
+                <a:spcPct val="150000"/>
+              </a:lnSpc>
+              <a:buNone/>
+            </a:pPr>
+            <a:r>
+              <a:rPr lang="en-US" sz="1200" dirty="0">
+                <a:solidFill>
+                  <a:srgbClr val="FFFFFF"/>
+                </a:solidFill>
+              </a:rPr>
+              <a:t>   Further studies are needed to determine the optimal timing and methods for immunotherapy in early-stage HCC.</a:t>
+            </a:r>
+            <a:endParaRPr lang="en-US" sz="1200" dirty="0"/>
+          </a:p>
+          <a:p>
+            <a:pPr indent="0" marL="0">
+              <a:lnSpc>
+                <a:spcPct val="150000"/>
+              </a:lnSpc>
+              <a:buNone/>
+            </a:pPr>
+            <a:endParaRPr lang="en-US" sz="1200" dirty="0"/>
+          </a:p>
+          <a:p>
+            <a:pPr indent="0" marL="0">
+              <a:lnSpc>
+                <a:spcPct val="150000"/>
+              </a:lnSpc>
+              <a:buNone/>
+            </a:pPr>
+            <a:r>
+              <a:rPr lang="en-US" sz="1200" dirty="0">
+                <a:solidFill>
+                  <a:srgbClr val="FFFFFF"/>
+                </a:solidFill>
+              </a:rPr>
+              <a:t>2. **腫瘤微環境的深入分析**  </a:t>
+            </a:r>
+            <a:endParaRPr lang="en-US" sz="1200" dirty="0"/>
+          </a:p>
+          <a:p>
+            <a:pPr indent="0" marL="0">
+              <a:lnSpc>
+                <a:spcPct val="150000"/>
+              </a:lnSpc>
+              <a:buNone/>
+            </a:pPr>
+            <a:r>
+              <a:rPr lang="en-US" sz="1200" dirty="0">
+                <a:solidFill>
+                  <a:srgbClr val="FFFFFF"/>
+                </a:solidFill>
+              </a:rPr>
+              <a:t>   **In-Depth Analysis of Tumor Microenvironment**  </a:t>
+            </a:r>
+            <a:endParaRPr lang="en-US" sz="1200" dirty="0"/>
+          </a:p>
+          <a:p>
+            <a:pPr indent="0" marL="0">
+              <a:lnSpc>
+                <a:spcPct val="150000"/>
+              </a:lnSpc>
+              <a:buNone/>
+            </a:pPr>
+            <a:r>
+              <a:rPr lang="en-US" sz="1200" dirty="0">
+                <a:solidFill>
+                  <a:srgbClr val="FFFFFF"/>
+                </a:solidFill>
+              </a:rPr>
+              <a:t>   研究腫瘤微環境中不同細胞類型的相互作用及其對免疫治療反應的影響。  </a:t>
+            </a:r>
+            <a:endParaRPr lang="en-US" sz="1200" dirty="0"/>
+          </a:p>
+          <a:p>
+            <a:pPr indent="0" marL="0">
+              <a:lnSpc>
+                <a:spcPct val="150000"/>
+              </a:lnSpc>
+              <a:buNone/>
+            </a:pPr>
+            <a:r>
+              <a:rPr lang="en-US" sz="1200" dirty="0">
+                <a:solidFill>
+                  <a:srgbClr val="FFFFFF"/>
+                </a:solidFill>
+              </a:rPr>
+              <a:t>   Investigate the interactions of different cell types within the tumor microenvironment and their impact on responses to immunotherapy.</a:t>
+            </a:r>
+            <a:endParaRPr lang="en-US" sz="1200" dirty="0"/>
+          </a:p>
+          <a:p>
+            <a:pPr indent="0" marL="0">
+              <a:lnSpc>
+                <a:spcPct val="150000"/>
+              </a:lnSpc>
+              <a:buNone/>
+            </a:pPr>
+            <a:endParaRPr lang="en-US" sz="1200" dirty="0"/>
+          </a:p>
+          <a:p>
+            <a:pPr indent="0" marL="0">
+              <a:lnSpc>
+                <a:spcPct val="150000"/>
+              </a:lnSpc>
+              <a:buNone/>
+            </a:pPr>
+            <a:r>
+              <a:rPr lang="en-US" sz="1200" dirty="0">
+                <a:solidFill>
+                  <a:srgbClr val="FFFFFF"/>
+                </a:solidFill>
+              </a:rPr>
+              <a:t>3. **新型治療靶點的發掘**  </a:t>
+            </a:r>
+            <a:endParaRPr lang="en-US" sz="1200" dirty="0"/>
+          </a:p>
+          <a:p>
+            <a:pPr indent="0" marL="0">
+              <a:lnSpc>
+                <a:spcPct val="150000"/>
+              </a:lnSpc>
+              <a:buNone/>
+            </a:pPr>
+            <a:r>
+              <a:rPr lang="en-US" sz="1200" dirty="0">
+                <a:solidFill>
+                  <a:srgbClr val="FFFFFF"/>
+                </a:solidFill>
+              </a:rPr>
+              <a:t>   **Discovery of Novel Therapeutic Targets**  </a:t>
+            </a:r>
+            <a:endParaRPr lang="en-US" sz="1200" dirty="0"/>
+          </a:p>
+          <a:p>
+            <a:pPr indent="0" marL="0">
+              <a:lnSpc>
+                <a:spcPct val="150000"/>
+              </a:lnSpc>
+              <a:buNone/>
+            </a:pPr>
+            <a:r>
+              <a:rPr lang="en-US" sz="1200" dirty="0">
+                <a:solidFill>
+                  <a:srgbClr val="FFFFFF"/>
+                </a:solidFill>
+              </a:rPr>
+              <a:t>   探索癌症相關成纖維細胞及其代謝途徑作為新療法的潛在靶點。  </a:t>
+            </a:r>
+            <a:endParaRPr lang="en-US" sz="1200" dirty="0"/>
+          </a:p>
+          <a:p>
+            <a:pPr indent="0" marL="0">
+              <a:lnSpc>
+                <a:spcPct val="150000"/>
+              </a:lnSpc>
+              <a:buNone/>
+            </a:pPr>
+            <a:r>
+              <a:rPr lang="en-US" sz="1200" dirty="0">
+                <a:solidFill>
+                  <a:srgbClr val="FFFFFF"/>
+                </a:solidFill>
+              </a:rPr>
+              <a:t>   Explore cancer-associated fibroblasts and their metabolic pathways as potential novel therapeutic targets.</a:t>
+            </a:r>
+            <a:endParaRPr lang="en-US" sz="1200" dirty="0"/>
+          </a:p>
+          <a:p>
+            <a:pPr indent="0" marL="0">
+              <a:lnSpc>
+                <a:spcPct val="150000"/>
+              </a:lnSpc>
+              <a:buNone/>
+            </a:pPr>
+            <a:endParaRPr lang="en-US" sz="1200" dirty="0"/>
+          </a:p>
+          <a:p>
+            <a:pPr indent="0" marL="0">
+              <a:lnSpc>
+                <a:spcPct val="150000"/>
+              </a:lnSpc>
+              <a:buNone/>
+            </a:pPr>
+            <a:r>
+              <a:rPr lang="en-US" sz="1200" dirty="0">
+                <a:solidFill>
+                  <a:srgbClr val="FFFFFF"/>
+                </a:solidFill>
+              </a:rPr>
+              <a:t>4. **多模式治療的臨床試驗**  </a:t>
+            </a:r>
+            <a:endParaRPr lang="en-US" sz="1200" dirty="0"/>
+          </a:p>
+          <a:p>
+            <a:pPr indent="0" marL="0">
+              <a:lnSpc>
+                <a:spcPct val="150000"/>
+              </a:lnSpc>
+              <a:buNone/>
+            </a:pPr>
+            <a:r>
+              <a:rPr lang="en-US" sz="1200" dirty="0">
+                <a:solidFill>
+                  <a:srgbClr val="FFFFFF"/>
+                </a:solidFill>
+              </a:rPr>
+              <a:t>   **Clinical Trials for Multimodal Therapies**  </a:t>
+            </a:r>
+            <a:endParaRPr lang="en-US" sz="1200" dirty="0"/>
+          </a:p>
+          <a:p>
+            <a:pPr indent="0" marL="0">
+              <a:lnSpc>
+                <a:spcPct val="150000"/>
+              </a:lnSpc>
+              <a:buNone/>
+            </a:pPr>
+            <a:r>
+              <a:rPr lang="en-US" sz="1200" dirty="0">
+                <a:solidFill>
+                  <a:srgbClr val="FFFFFF"/>
+                </a:solidFill>
+              </a:rPr>
+              <a:t>   設計臨床試驗以評估多種治療組合在不可切除HCC中的療效和安全性。  </a:t>
+            </a:r>
+            <a:endParaRPr lang="en-US" sz="1200" dirty="0"/>
+          </a:p>
+          <a:p>
+            <a:pPr indent="0" marL="0">
+              <a:lnSpc>
+                <a:spcPct val="150000"/>
+              </a:lnSpc>
+              <a:buNone/>
+            </a:pPr>
+            <a:r>
+              <a:rPr lang="en-US" sz="1200" dirty="0">
+                <a:solidFill>
+                  <a:srgbClr val="FFFFFF"/>
+                </a:solidFill>
+              </a:rPr>
+              <a:t>   Design clinical trials to assess the efficacy and safety of various treatment combinations in unresectable HCC.</a:t>
+            </a:r>
+            <a:endParaRPr lang="en-US" sz="1200" dirty="0"/>
+          </a:p>
+          <a:p>
+            <a:pPr indent="0" marL="0">
+              <a:lnSpc>
+                <a:spcPct val="150000"/>
+              </a:lnSpc>
+              <a:buNone/>
+            </a:pPr>
+            <a:endParaRPr lang="en-US" sz="1200" dirty="0"/>
+          </a:p>
+          <a:p>
+            <a:pPr indent="0" marL="0">
+              <a:lnSpc>
+                <a:spcPct val="150000"/>
+              </a:lnSpc>
+              <a:buNone/>
+            </a:pPr>
+            <a:r>
+              <a:rPr lang="en-US" sz="1200" dirty="0">
+                <a:solidFill>
+                  <a:srgbClr val="FFFFFF"/>
+                </a:solidFill>
+              </a:rPr>
+              <a:t>5. **個體化治療策略的發展**  </a:t>
+            </a:r>
+            <a:endParaRPr lang="en-US" sz="1200" dirty="0"/>
+          </a:p>
+          <a:p>
+            <a:pPr indent="0" marL="0">
+              <a:lnSpc>
+                <a:spcPct val="150000"/>
+              </a:lnSpc>
+              <a:buNone/>
+            </a:pPr>
+            <a:r>
+              <a:rPr lang="en-US" sz="1200" dirty="0">
+                <a:solidFill>
+                  <a:srgbClr val="FFFFFF"/>
+                </a:solidFill>
+              </a:rPr>
+              <a:t>   **Development of Personalized Treatment Strategies**  </a:t>
+            </a:r>
+            <a:endParaRPr lang="en-US" sz="1200" dirty="0"/>
+          </a:p>
+          <a:p>
+            <a:pPr indent="0" marL="0">
+              <a:lnSpc>
+                <a:spcPct val="150000"/>
+              </a:lnSpc>
+              <a:buNone/>
+            </a:pPr>
+            <a:r>
+              <a:rPr lang="en-US" sz="1200" dirty="0">
+                <a:solidFill>
+                  <a:srgbClr val="FFFFFF"/>
+                </a:solidFill>
+              </a:rPr>
+              <a:t>   研究個體化治療策略，以根據患者的腫瘤特徵和免疫狀態調整治療方案。  </a:t>
+            </a:r>
+            <a:endParaRPr lang="en-US" sz="1200" dirty="0"/>
+          </a:p>
+          <a:p>
+            <a:pPr indent="0" marL="0">
+              <a:lnSpc>
+                <a:spcPct val="150000"/>
+              </a:lnSpc>
+              <a:buNone/>
+            </a:pPr>
+            <a:r>
+              <a:rPr lang="en-US" sz="1200" dirty="0">
+                <a:solidFill>
+                  <a:srgbClr val="FFFFFF"/>
+                </a:solidFill>
+              </a:rPr>
+              <a:t>   Investigate personalized treatment strategies that tailor therapeutic approaches based on individual tumor characteristics and immune status.</a:t>
+            </a:r>
+            <a:endParaRPr lang="en-US" sz="1200" dirty="0"/>
+          </a:p>
+        </p:txBody>
+      </p:sp>
+    </p:spTree>
+  </p:cSld>
+  <p:clrMapOvr>
+    <a:masterClrMapping/>
+  </p:clrMapOvr>
+</p:sld>
+</file>
+
+<file path=ppt/slides/slide15.xml><?xml version="1.0" encoding="utf-8"?>
+<p:sld xmlns:a="http://schemas.openxmlformats.org/drawingml/2006/main" xmlns:r="http://schemas.openxmlformats.org/officeDocument/2006/relationships" xmlns:p="http://schemas.openxmlformats.org/presentationml/2006/main">
+  <p:cSld name="Slide 15">
     <p:bg>
       <p:bgPr>
         <a:solidFill>
@@ -4981,7 +5215,7 @@
                 <a:ea typeface="Arial" pitchFamily="34" charset="-122"/>
                 <a:cs typeface="Arial" pitchFamily="34" charset="-120"/>
               </a:rPr>
-              <a:t>Hallmarks of cancer guide treatment strategies.</a:t>
+              <a:t>Cancer hallmarks guide treatment strategies.</a:t>
             </a:r>
             <a:endParaRPr lang="en-US" sz="1800" dirty="0"/>
           </a:p>
@@ -5002,7 +5236,7 @@
                 <a:ea typeface="Arial" pitchFamily="34" charset="-122"/>
                 <a:cs typeface="Arial" pitchFamily="34" charset="-120"/>
               </a:rPr>
-              <a:t>HCC shows unique characteristics like immune evasion.</a:t>
+              <a:t>HCC shows unique immune evasion traits.</a:t>
             </a:r>
             <a:endParaRPr lang="en-US" sz="1800" dirty="0"/>
           </a:p>
@@ -5023,49 +5257,7 @@
                 <a:ea typeface="Arial" pitchFamily="34" charset="-122"/>
                 <a:cs typeface="Arial" pitchFamily="34" charset="-120"/>
               </a:rPr>
-              <a:t>Immunotherapies have improved advanced HCC outcomes.</a:t>
-            </a:r>
-            <a:endParaRPr lang="en-US" sz="1800" dirty="0"/>
-          </a:p>
-          <a:p>
-            <a:pPr marL="342900" indent="-342900">
-              <a:spcAft>
-                <a:spcPts val="800"/>
-              </a:spcAft>
-              <a:buSzPct val="100000"/>
-              <a:buChar char="•"/>
-            </a:pPr>
-            <a:r>
-              <a:rPr lang="en-US" sz="1800" dirty="0">
-                <a:solidFill>
-                  <a:srgbClr val="333333"/>
-                </a:solidFill>
-                <a:latin typeface="Arial" pitchFamily="34" charset="0"/>
-                <a:ea typeface="Arial" pitchFamily="34" charset="-122"/>
-                <a:cs typeface="Arial" pitchFamily="34" charset="-120"/>
-              </a:rPr>
-              <a:t>iCCA has distinct genetic alterations for precision therapy.</a:t>
-            </a:r>
-            <a:endParaRPr lang="en-US" sz="1800" dirty="0"/>
-          </a:p>
-          <a:p>
-            <a:pPr marL="342900" indent="-342900">
-              <a:spcAft>
-                <a:spcPts val="800"/>
-              </a:spcAft>
-              <a:buSzPct val="100000"/>
-              <a:buChar char="•"/>
-            </a:pPr>
-            <a:r>
-              <a:rPr lang="en-US" sz="1800" dirty="0">
-                <a:solidFill>
-                  <a:srgbClr val="333333"/>
-                </a:solidFill>
-                <a:latin typeface="Arial" pitchFamily="34" charset="0"/>
-                <a:ea typeface="Arial" pitchFamily="34" charset="-122"/>
-                <a:cs typeface="Arial" pitchFamily="34" charset="-120"/>
-              </a:rPr>
-              <a:t>Future strategies may enhance liver cancer management.</a:t>
+              <a:t>iCCA has distinct genetic alterations.</a:t>
             </a:r>
             <a:endParaRPr lang="en-US" sz="1800" dirty="0"/>
           </a:p>
@@ -5365,7 +5557,7 @@
                 <a:ea typeface="Arial" pitchFamily="34" charset="-122"/>
                 <a:cs typeface="Arial" pitchFamily="34" charset="-120"/>
               </a:rPr>
-              <a:t>Pilot study with 8 resectable HCC patients</a:t>
+              <a:t>Pilot study with 8 HCC patients</a:t>
             </a:r>
             <a:endParaRPr lang="en-US" sz="1800" dirty="0"/>
           </a:p>
@@ -5386,7 +5578,7 @@
                 <a:ea typeface="Arial" pitchFamily="34" charset="-122"/>
                 <a:cs typeface="Arial" pitchFamily="34" charset="-120"/>
               </a:rPr>
-              <a:t>Safety endpoint: only one grade 3 adverse event</a:t>
+              <a:t>High safety with low adverse events</a:t>
             </a:r>
             <a:endParaRPr lang="en-US" sz="1800" dirty="0"/>
           </a:p>
@@ -5407,7 +5599,7 @@
                 <a:ea typeface="Arial" pitchFamily="34" charset="-122"/>
                 <a:cs typeface="Arial" pitchFamily="34" charset="-120"/>
               </a:rPr>
-              <a:t>All resected patients achieved R0 resection</a:t>
+              <a:t>Significant immune infiltration observed</a:t>
             </a:r>
             <a:endParaRPr lang="en-US" sz="1800" dirty="0"/>
           </a:p>
@@ -5428,7 +5620,7 @@
                 <a:ea typeface="Arial" pitchFamily="34" charset="-122"/>
                 <a:cs typeface="Arial" pitchFamily="34" charset="-120"/>
               </a:rPr>
-              <a:t>Increased anti-cancer immune infiltration observed</a:t>
+              <a:t>All resected patients relapse-free</a:t>
             </a:r>
             <a:endParaRPr lang="en-US" sz="1800" dirty="0"/>
           </a:p>
@@ -5707,7 +5899,7 @@
                 <a:ea typeface="Arial" pitchFamily="34" charset="-122"/>
                 <a:cs typeface="Arial" pitchFamily="34" charset="-120"/>
               </a:rPr>
-              <a:t>Hepatectomy impacts anti-PD-1 therapy</a:t>
+              <a:t>Hepatectomy affects anti-PD-1 therapy</a:t>
             </a:r>
             <a:endParaRPr lang="en-US" sz="1800" dirty="0"/>
           </a:p>
@@ -5728,7 +5920,7 @@
                 <a:ea typeface="Arial" pitchFamily="34" charset="-122"/>
                 <a:cs typeface="Arial" pitchFamily="34" charset="-120"/>
               </a:rPr>
-              <a:t>Study conducted in mouse HCC model</a:t>
+              <a:t>Mouse model used for HCC study</a:t>
             </a:r>
             <a:endParaRPr lang="en-US" sz="1800" dirty="0"/>
           </a:p>
@@ -6049,7 +6241,7 @@
                 <a:ea typeface="Arial" pitchFamily="34" charset="-122"/>
                 <a:cs typeface="Arial" pitchFamily="34" charset="-120"/>
               </a:rPr>
-              <a:t>Higher Lactobacillus levels predict disease-free survival.</a:t>
+              <a:t>Higher levels correlate with disease-free survival.</a:t>
             </a:r>
             <a:endParaRPr lang="en-US" sz="1800" dirty="0"/>
           </a:p>
@@ -6070,7 +6262,7 @@
                 <a:ea typeface="Arial" pitchFamily="34" charset="-122"/>
                 <a:cs typeface="Arial" pitchFamily="34" charset="-120"/>
               </a:rPr>
-              <a:t>Nicotinic acid activates NF-κB pathway in T cells.</a:t>
+              <a:t>Nicotinic acid activates NF-κB pathway.</a:t>
             </a:r>
             <a:endParaRPr lang="en-US" sz="1800" dirty="0"/>
           </a:p>
@@ -6091,7 +6283,7 @@
                 <a:ea typeface="Arial" pitchFamily="34" charset="-122"/>
                 <a:cs typeface="Arial" pitchFamily="34" charset="-120"/>
               </a:rPr>
-              <a:t>Combination therapy reduces tumor growth and relapse.</a:t>
+              <a:t>Combination therapy reduces tumor relapse.</a:t>
             </a:r>
             <a:endParaRPr lang="en-US" sz="1800" dirty="0"/>
           </a:p>
@@ -6112,7 +6304,7 @@
                 <a:ea typeface="Arial" pitchFamily="34" charset="-122"/>
                 <a:cs typeface="Arial" pitchFamily="34" charset="-120"/>
               </a:rPr>
-              <a:t>CD8+ T cells are crucial for L. johnsonii efficacy.</a:t>
+              <a:t>CD8+ T cells are crucial for efficacy.</a:t>
             </a:r>
             <a:endParaRPr lang="en-US" sz="1800" dirty="0"/>
           </a:p>
@@ -6391,7 +6583,7 @@
                 <a:ea typeface="Arial" pitchFamily="34" charset="-122"/>
                 <a:cs typeface="Arial" pitchFamily="34" charset="-120"/>
               </a:rPr>
-              <a:t>CAFs induce immunosuppression in HCC.</a:t>
+              <a:t>CAFs drive immunosuppression in HCC.</a:t>
             </a:r>
             <a:endParaRPr lang="en-US" sz="1800" dirty="0"/>
           </a:p>
@@ -6433,7 +6625,7 @@
                 <a:ea typeface="Arial" pitchFamily="34" charset="-122"/>
                 <a:cs typeface="Arial" pitchFamily="34" charset="-120"/>
               </a:rPr>
-              <a:t>ANGPTL4 enhances PD-L1 expression.</a:t>
+              <a:t>ANGPTL4 enhances tumor immune evasion.</a:t>
             </a:r>
             <a:endParaRPr lang="en-US" sz="1800" dirty="0"/>
           </a:p>
@@ -6475,7 +6667,7 @@
                 <a:ea typeface="Arial" pitchFamily="34" charset="-122"/>
                 <a:cs typeface="Arial" pitchFamily="34" charset="-120"/>
               </a:rPr>
-              <a:t>Combination therapy improves immunotherapy outcomes.</a:t>
+              <a:t>Synergistic effect with anti-PD-L1 therapy.</a:t>
             </a:r>
             <a:endParaRPr lang="en-US" sz="1800" dirty="0"/>
           </a:p>
@@ -6754,7 +6946,7 @@
                 <a:ea typeface="Arial" pitchFamily="34" charset="-122"/>
                 <a:cs typeface="Arial" pitchFamily="34" charset="-120"/>
               </a:rPr>
-              <a:t>Fc region influences PD-1 therapy efficacy.</a:t>
+              <a:t>Fc region affects PD-1 therapy efficacy.</a:t>
             </a:r>
             <a:endParaRPr lang="en-US" sz="1800" dirty="0"/>
           </a:p>
@@ -6775,7 +6967,7 @@
                 <a:ea typeface="Arial" pitchFamily="34" charset="-122"/>
                 <a:cs typeface="Arial" pitchFamily="34" charset="-120"/>
               </a:rPr>
-              <a:t>Depletion of PD-1+ CD8 T cells in liver.</a:t>
+              <a:t>Depletion of virus-specific CD8 T cells.</a:t>
             </a:r>
             <a:endParaRPr lang="en-US" sz="1800" dirty="0"/>
           </a:p>
@@ -6796,49 +6988,7 @@
                 <a:ea typeface="Arial" pitchFamily="34" charset="-122"/>
                 <a:cs typeface="Arial" pitchFamily="34" charset="-120"/>
               </a:rPr>
-              <a:t>Fc-dependent effects on viral titers.</a:t>
-            </a:r>
-            <a:endParaRPr lang="en-US" sz="1800" dirty="0"/>
-          </a:p>
-          <a:p>
-            <a:pPr marL="342900" indent="-342900">
-              <a:spcAft>
-                <a:spcPts val="800"/>
-              </a:spcAft>
-              <a:buSzPct val="100000"/>
-              <a:buChar char="•"/>
-            </a:pPr>
-            <a:r>
-              <a:rPr lang="en-US" sz="1800" dirty="0">
-                <a:solidFill>
-                  <a:srgbClr val="333333"/>
-                </a:solidFill>
-                <a:latin typeface="Arial" pitchFamily="34" charset="0"/>
-                <a:ea typeface="Arial" pitchFamily="34" charset="-122"/>
-                <a:cs typeface="Arial" pitchFamily="34" charset="-120"/>
-              </a:rPr>
               <a:t>Phagocytic cells mediate T cell depletion.</a:t>
-            </a:r>
-            <a:endParaRPr lang="en-US" sz="1800" dirty="0"/>
-          </a:p>
-          <a:p>
-            <a:pPr marL="342900" indent="-342900">
-              <a:spcAft>
-                <a:spcPts val="800"/>
-              </a:spcAft>
-              <a:buSzPct val="100000"/>
-              <a:buChar char="•"/>
-            </a:pPr>
-            <a:r>
-              <a:rPr lang="en-US" sz="1800" dirty="0">
-                <a:solidFill>
-                  <a:srgbClr val="333333"/>
-                </a:solidFill>
-                <a:latin typeface="Arial" pitchFamily="34" charset="0"/>
-                <a:ea typeface="Arial" pitchFamily="34" charset="-122"/>
-                <a:cs typeface="Arial" pitchFamily="34" charset="-120"/>
-              </a:rPr>
-              <a:t>Implications for liver cancer therapies.</a:t>
             </a:r>
             <a:endParaRPr lang="en-US" sz="1800" dirty="0"/>
           </a:p>
@@ -7138,7 +7288,7 @@
                 <a:ea typeface="Arial" pitchFamily="34" charset="-122"/>
                 <a:cs typeface="Arial" pitchFamily="34" charset="-120"/>
               </a:rPr>
-              <a:t>HAIC combined with lenvatinib and PD-1 inhibitors</a:t>
+              <a:t>HAIC combined with lenvatinib and PD-1</a:t>
             </a:r>
             <a:endParaRPr lang="en-US" sz="1800" dirty="0"/>
           </a:p>
@@ -7159,7 +7309,7 @@
                 <a:ea typeface="Arial" pitchFamily="34" charset="-122"/>
                 <a:cs typeface="Arial" pitchFamily="34" charset="-120"/>
               </a:rPr>
-              <a:t>Comparative efficacy against lenvatinib and PD-1 alone</a:t>
+              <a:t>Improved outcomes compared to monotherapy</a:t>
             </a:r>
             <a:endParaRPr lang="en-US" sz="1800" dirty="0"/>
           </a:p>
@@ -7180,7 +7330,7 @@
                 <a:ea typeface="Arial" pitchFamily="34" charset="-122"/>
                 <a:cs typeface="Arial" pitchFamily="34" charset="-120"/>
               </a:rPr>
-              <a:t>Focus on poor prognosis to curative strategies</a:t>
+              <a:t>Potential for curative-intent strategies</a:t>
             </a:r>
             <a:endParaRPr lang="en-US" sz="1800" dirty="0"/>
           </a:p>
@@ -7201,7 +7351,7 @@
                 <a:ea typeface="Arial" pitchFamily="34" charset="-122"/>
                 <a:cs typeface="Arial" pitchFamily="34" charset="-120"/>
               </a:rPr>
-              <a:t>Potential for improved patient outcomes</a:t>
+              <a:t>Focus on advanced hepatocellular carcinoma</a:t>
             </a:r>
             <a:endParaRPr lang="en-US" sz="1800" dirty="0"/>
           </a:p>

</xml_diff>

<commit_message>
feat: add reference line at bottom of each paper slide
</commit_message>
<xml_diff>
--- a/docs/digest-en.pptx
+++ b/docs/digest-en.pptx
@@ -2560,7 +2560,7 @@
                 <a:ea typeface="Arial" pitchFamily="34" charset="-122"/>
                 <a:cs typeface="Arial" pitchFamily="34" charset="-120"/>
               </a:rPr>
-              <a:t>Transarterial chemoembolization (TACE) used</a:t>
+              <a:t>Transarterial chemoembolization and PD-1 inhibitors</a:t>
             </a:r>
             <a:endParaRPr lang="en-US" sz="1800" dirty="0"/>
           </a:p>
@@ -2581,57 +2581,51 @@
                 <a:ea typeface="Arial" pitchFamily="34" charset="-122"/>
                 <a:cs typeface="Arial" pitchFamily="34" charset="-120"/>
               </a:rPr>
-              <a:t>PD-1 inhibitors enhance treatment efficacy</a:t>
+              <a:t>Phase 2 trial results show efficacy</a:t>
             </a:r>
             <a:endParaRPr lang="en-US" sz="1800" dirty="0"/>
           </a:p>
-          <a:p>
-            <a:pPr marL="342900" indent="-342900">
-              <a:spcAft>
-                <a:spcPts val="800"/>
-              </a:spcAft>
-              <a:buSzPct val="100000"/>
-              <a:buChar char="•"/>
-            </a:pPr>
-            <a:r>
-              <a:rPr lang="en-US" sz="1800" dirty="0">
-                <a:solidFill>
-                  <a:srgbClr val="333333"/>
-                </a:solidFill>
-                <a:latin typeface="Arial" pitchFamily="34" charset="0"/>
-                <a:ea typeface="Arial" pitchFamily="34" charset="-122"/>
-                <a:cs typeface="Arial" pitchFamily="34" charset="-120"/>
-              </a:rPr>
-              <a:t>Phase 2 trial demonstrates promising results</a:t>
-            </a:r>
-            <a:endParaRPr lang="en-US" sz="1800" dirty="0"/>
-          </a:p>
-          <a:p>
-            <a:pPr marL="342900" indent="-342900">
-              <a:spcAft>
-                <a:spcPts val="800"/>
-              </a:spcAft>
-              <a:buSzPct val="100000"/>
-              <a:buChar char="•"/>
-            </a:pPr>
-            <a:r>
-              <a:rPr lang="en-US" sz="1800" dirty="0">
-                <a:solidFill>
-                  <a:srgbClr val="333333"/>
-                </a:solidFill>
-                <a:latin typeface="Arial" pitchFamily="34" charset="0"/>
-                <a:ea typeface="Arial" pitchFamily="34" charset="-122"/>
-                <a:cs typeface="Arial" pitchFamily="34" charset="-120"/>
-              </a:rPr>
-              <a:t>Potential for conversion to surgical options</a:t>
-            </a:r>
-            <a:endParaRPr lang="en-US" sz="1800" dirty="0"/>
-          </a:p>
-        </p:txBody>
-      </p:sp>
-      <p:sp>
-        <p:nvSpPr>
-          <p:cNvPr id="7" name="Text 5">
+        </p:txBody>
+      </p:sp>
+      <p:sp>
+        <p:nvSpPr>
+          <p:cNvPr id="7" name="Text 5"/>
+          <p:cNvSpPr/>
+          <p:nvPr/>
+        </p:nvSpPr>
+        <p:spPr>
+          <a:xfrm>
+            <a:off x="731520" y="5852160"/>
+            <a:ext cx="10058400" cy="0"/>
+          </a:xfrm>
+          <a:prstGeom prst="rect">
+            <a:avLst/>
+          </a:prstGeom>
+          <a:noFill/>
+          <a:ln/>
+        </p:spPr>
+        <p:txBody>
+          <a:bodyPr wrap="square" lIns="0" tIns="0" rIns="0" bIns="0" rtlCol="0" anchor="ctr"/>
+          <a:lstStyle/>
+          <a:p>
+            <a:pPr indent="0" marL="0">
+              <a:buNone/>
+            </a:pPr>
+            <a:r>
+              <a:rPr lang="en-US" sz="800" dirty="0">
+                <a:solidFill>
+                  <a:srgbClr val="888888"/>
+                </a:solidFill>
+              </a:rPr>
+              <a:t>X Zhang, H Cai, W Peng. … and Targeted Therapy. 2026</a:t>
+            </a:r>
+            <a:endParaRPr lang="en-US" sz="800" dirty="0"/>
+          </a:p>
+        </p:txBody>
+      </p:sp>
+      <p:sp>
+        <p:nvSpPr>
+          <p:cNvPr id="8" name="Text 6">
             <a:hlinkClick r:id="rId2" tooltip=""/>
           </p:cNvPr>
           <p:cNvSpPr/>
@@ -2902,7 +2896,7 @@
                 <a:ea typeface="Arial" pitchFamily="34" charset="-122"/>
                 <a:cs typeface="Arial" pitchFamily="34" charset="-120"/>
               </a:rPr>
-              <a:t>Atez+Bev shows 25% ORR in HCC patients.</a:t>
+              <a:t>Atez+Bev shows efficacy after Dur+Tre</a:t>
             </a:r>
             <a:endParaRPr lang="en-US" sz="1800" dirty="0"/>
           </a:p>
@@ -2923,7 +2917,7 @@
                 <a:ea typeface="Arial" pitchFamily="34" charset="-122"/>
                 <a:cs typeface="Arial" pitchFamily="34" charset="-120"/>
               </a:rPr>
-              <a:t>75% DCR indicates favorable disease control.</a:t>
+              <a:t>Objective response rate is 25.0%</a:t>
             </a:r>
             <a:endParaRPr lang="en-US" sz="1800" dirty="0"/>
           </a:p>
@@ -2944,57 +2938,51 @@
                 <a:ea typeface="Arial" pitchFamily="34" charset="-122"/>
                 <a:cs typeface="Arial" pitchFamily="34" charset="-120"/>
               </a:rPr>
-              <a:t>Prior Dur+Tre may enhance immune response.</a:t>
+              <a:t>Adverse events differ between regimens</a:t>
             </a:r>
             <a:endParaRPr lang="en-US" sz="1800" dirty="0"/>
           </a:p>
-          <a:p>
-            <a:pPr marL="342900" indent="-342900">
-              <a:spcAft>
-                <a:spcPts val="800"/>
-              </a:spcAft>
-              <a:buSzPct val="100000"/>
-              <a:buChar char="•"/>
-            </a:pPr>
-            <a:r>
-              <a:rPr lang="en-US" sz="1800" dirty="0">
-                <a:solidFill>
-                  <a:srgbClr val="333333"/>
-                </a:solidFill>
-                <a:latin typeface="Arial" pitchFamily="34" charset="0"/>
-                <a:ea typeface="Arial" pitchFamily="34" charset="-122"/>
-                <a:cs typeface="Arial" pitchFamily="34" charset="-120"/>
-              </a:rPr>
-              <a:t>Common adverse events include pruritus and proteinuria.</a:t>
-            </a:r>
-            <a:endParaRPr lang="en-US" sz="1800" dirty="0"/>
-          </a:p>
-          <a:p>
-            <a:pPr marL="342900" indent="-342900">
-              <a:spcAft>
-                <a:spcPts val="800"/>
-              </a:spcAft>
-              <a:buSzPct val="100000"/>
-              <a:buChar char="•"/>
-            </a:pPr>
-            <a:r>
-              <a:rPr lang="en-US" sz="1800" dirty="0">
-                <a:solidFill>
-                  <a:srgbClr val="333333"/>
-                </a:solidFill>
-                <a:latin typeface="Arial" pitchFamily="34" charset="0"/>
-                <a:ea typeface="Arial" pitchFamily="34" charset="-122"/>
-                <a:cs typeface="Arial" pitchFamily="34" charset="-120"/>
-              </a:rPr>
-              <a:t>Sequential therapy offers new treatment options.</a:t>
-            </a:r>
-            <a:endParaRPr lang="en-US" sz="1800" dirty="0"/>
-          </a:p>
-        </p:txBody>
-      </p:sp>
-      <p:sp>
-        <p:nvSpPr>
-          <p:cNvPr id="7" name="Text 5">
+        </p:txBody>
+      </p:sp>
+      <p:sp>
+        <p:nvSpPr>
+          <p:cNvPr id="7" name="Text 5"/>
+          <p:cNvSpPr/>
+          <p:nvPr/>
+        </p:nvSpPr>
+        <p:spPr>
+          <a:xfrm>
+            <a:off x="731520" y="5852160"/>
+            <a:ext cx="10058400" cy="0"/>
+          </a:xfrm>
+          <a:prstGeom prst="rect">
+            <a:avLst/>
+          </a:prstGeom>
+          <a:noFill/>
+          <a:ln/>
+        </p:spPr>
+        <p:txBody>
+          <a:bodyPr wrap="square" lIns="0" tIns="0" rIns="0" bIns="0" rtlCol="0" anchor="ctr"/>
+          <a:lstStyle/>
+          <a:p>
+            <a:pPr indent="0" marL="0">
+              <a:buNone/>
+            </a:pPr>
+            <a:r>
+              <a:rPr lang="en-US" sz="800" dirty="0">
+                <a:solidFill>
+                  <a:srgbClr val="888888"/>
+                </a:solidFill>
+              </a:rPr>
+              <a:t>Uchikawa Shinsuke, Kawaoka Tomokazu, Tanaka Aiko et al.. Internal medicine (Tokyo, Japan). 2026-04-16 DOI: 10.2169/internalmedicine.6021-25</a:t>
+            </a:r>
+            <a:endParaRPr lang="en-US" sz="800" dirty="0"/>
+          </a:p>
+        </p:txBody>
+      </p:sp>
+      <p:sp>
+        <p:nvSpPr>
+          <p:cNvPr id="8" name="Text 6">
             <a:hlinkClick r:id="rId2" tooltip=""/>
           </p:cNvPr>
           <p:cNvSpPr/>
@@ -3307,7 +3295,7 @@
                 <a:ea typeface="Arial" pitchFamily="34" charset="-122"/>
                 <a:cs typeface="Arial" pitchFamily="34" charset="-120"/>
               </a:rPr>
-              <a:t>Evaluation of local progression-free survival</a:t>
+              <a:t>Analysis of local progression-free survival</a:t>
             </a:r>
             <a:endParaRPr lang="en-US" sz="1800" dirty="0"/>
           </a:p>
@@ -3357,7 +3345,43 @@
       </p:sp>
       <p:sp>
         <p:nvSpPr>
-          <p:cNvPr id="7" name="Text 5">
+          <p:cNvPr id="7" name="Text 5"/>
+          <p:cNvSpPr/>
+          <p:nvPr/>
+        </p:nvSpPr>
+        <p:spPr>
+          <a:xfrm>
+            <a:off x="731520" y="5852160"/>
+            <a:ext cx="10058400" cy="0"/>
+          </a:xfrm>
+          <a:prstGeom prst="rect">
+            <a:avLst/>
+          </a:prstGeom>
+          <a:noFill/>
+          <a:ln/>
+        </p:spPr>
+        <p:txBody>
+          <a:bodyPr wrap="square" lIns="0" tIns="0" rIns="0" bIns="0" rtlCol="0" anchor="ctr"/>
+          <a:lstStyle/>
+          <a:p>
+            <a:pPr indent="0" marL="0">
+              <a:buNone/>
+            </a:pPr>
+            <a:r>
+              <a:rPr lang="en-US" sz="800" dirty="0">
+                <a:solidFill>
+                  <a:srgbClr val="888888"/>
+                </a:solidFill>
+              </a:rPr>
+              <a:t>SH Bae, SH Choi, SM Yoon. Journal of Clinical …. 2026</a:t>
+            </a:r>
+            <a:endParaRPr lang="en-US" sz="800" dirty="0"/>
+          </a:p>
+        </p:txBody>
+      </p:sp>
+      <p:sp>
+        <p:nvSpPr>
+          <p:cNvPr id="8" name="Text 6">
             <a:hlinkClick r:id="rId2" tooltip=""/>
           </p:cNvPr>
           <p:cNvSpPr/>
@@ -3566,7 +3590,7 @@
                   <a:srgbClr val="FFFFFF"/>
                 </a:solidFill>
               </a:rPr>
-              <a:t>1. **免疫療法的潛力**  </a:t>
+              <a:t>1. **免疫治療的潛力**  </a:t>
             </a:r>
             <a:endParaRPr lang="en-US" sz="1200" dirty="0"/>
           </a:p>
@@ -3583,7 +3607,7 @@
                   <a:srgbClr val="FFFFFF"/>
                 </a:solidFill>
               </a:rPr>
-              <a:t>   Immunotherapy has shown significant promise in enhancing treatment outcomes for hepatocellular carcinoma (HCC), particularly in advanced stages.  </a:t>
+              <a:t>   The integration of immune therapy with traditional treatments, such as surgical resection and local ablation, shows promise in enhancing patient outcomes in hepatocellular carcinoma (HCC).  </a:t>
             </a:r>
             <a:endParaRPr lang="en-US" sz="1200" dirty="0"/>
           </a:p>
@@ -3600,7 +3624,7 @@
                   <a:srgbClr val="FFFFFF"/>
                 </a:solidFill>
               </a:rPr>
-              <a:t>   免疫療法在改善肝細胞癌（HCC）治療結果方面顯示出顯著潛力，特別是在晚期階段。</a:t>
+              <a:t>   免疫治療與傳統療法（如手術切除和局部消融）的結合顯示出改善肝細胞癌（HCC）患者預後的潛力。</a:t>
             </a:r>
             <a:endParaRPr lang="en-US" sz="1200" dirty="0"/>
           </a:p>
@@ -3643,7 +3667,7 @@
                   <a:srgbClr val="FFFFFF"/>
                 </a:solidFill>
               </a:rPr>
-              <a:t>   Neoadjuvant therapies, including stereotactic body radiation therapy combined with immune therapy, can favorably remodel the tumor microenvironment, promoting a more effective immune response.  </a:t>
+              <a:t>   Neoadjuvant therapies that remodel the tumor microenvironment can significantly improve the efficacy of subsequent immune treatments, suggesting a need for early intervention strategies.  </a:t>
             </a:r>
             <a:endParaRPr lang="en-US" sz="1200" dirty="0"/>
           </a:p>
@@ -3660,7 +3684,7 @@
                   <a:srgbClr val="FFFFFF"/>
                 </a:solidFill>
               </a:rPr>
-              <a:t>   新輔助療法，包括立體定向體部放射療法結合免疫療法，可以有利於重塑腫瘤微環境，促進更有效的免疫反應。</a:t>
+              <a:t>   重塑腫瘤微環境的術前療法可以顯著提高隨後免疫治療的療效，這表明需要早期介入策略。</a:t>
             </a:r>
             <a:endParaRPr lang="en-US" sz="1200" dirty="0"/>
           </a:p>
@@ -3703,7 +3727,7 @@
                   <a:srgbClr val="FFFFFF"/>
                 </a:solidFill>
               </a:rPr>
-              <a:t>   Cancer-associated fibroblasts (CAFs) play a crucial role in tumor immunosuppression through metabolic pathways, indicating potential therapeutic targets for enhancing immunotherapy efficacy.  </a:t>
+              <a:t>   Cancer-associated fibroblasts (CAFs) play a crucial role in promoting immunosuppression in HCC, highlighting the importance of targeting these cells to enhance immune responses.  </a:t>
             </a:r>
             <a:endParaRPr lang="en-US" sz="1200" dirty="0"/>
           </a:p>
@@ -3720,7 +3744,7 @@
                   <a:srgbClr val="FFFFFF"/>
                 </a:solidFill>
               </a:rPr>
-              <a:t>   癌症相關成纖維細胞（CAFs）在腫瘤免疫抑制中扮演關鍵角色，透過代謝途徑顯示出增強免疫療法療效的潛在治療靶點。</a:t>
+              <a:t>   癌症相關成纖維細胞（CAFs）在促進HCC中的免疫抑制方面扮演著關鍵角色，強調了針對這些細胞以增強免疫反應的重要性。</a:t>
             </a:r>
             <a:endParaRPr lang="en-US" sz="1200" dirty="0"/>
           </a:p>
@@ -3746,7 +3770,7 @@
                   <a:srgbClr val="FFFFFF"/>
                 </a:solidFill>
               </a:rPr>
-              <a:t>4. **手術後復發的挑戰**  </a:t>
+              <a:t>4. **病毒特異性T細胞的耗竭**  </a:t>
             </a:r>
             <a:endParaRPr lang="en-US" sz="1200" dirty="0"/>
           </a:p>
@@ -3763,7 +3787,7 @@
                   <a:srgbClr val="FFFFFF"/>
                 </a:solidFill>
               </a:rPr>
-              <a:t>   Despite the effectiveness of surgical resection for early-stage HCC, postoperative recurrence remains a significant clinical challenge that necessitates further investigation into underlying mechanisms.  </a:t>
+              <a:t>   The selective depletion of virus-specific CD8 T cells during PD-1 therapy underscores the complexity of immune responses in chronic infections and their implications for HCC treatment.  </a:t>
             </a:r>
             <a:endParaRPr lang="en-US" sz="1200" dirty="0"/>
           </a:p>
@@ -3780,7 +3804,7 @@
                   <a:srgbClr val="FFFFFF"/>
                 </a:solidFill>
               </a:rPr>
-              <a:t>   儘管手術切除對早期HCC有效，但術後復發仍然是一個重大臨床挑戰，需進一步研究其潛在機制。</a:t>
+              <a:t>   在PD-1治療過程中病毒特異性CD8 T細胞的選擇性耗竭突顯了慢性感染中免疫反應的複雜性及其對HCC治療的影響。</a:t>
             </a:r>
             <a:endParaRPr lang="en-US" sz="1200" dirty="0"/>
           </a:p>
@@ -3806,7 +3830,7 @@
                   <a:srgbClr val="FFFFFF"/>
                 </a:solidFill>
               </a:rPr>
-              <a:t>5. **多模式治療的前景**  </a:t>
+              <a:t>5. **多模式療法的必要性**  </a:t>
             </a:r>
             <a:endParaRPr lang="en-US" sz="1200" dirty="0"/>
           </a:p>
@@ -3823,7 +3847,7 @@
                   <a:srgbClr val="FFFFFF"/>
                 </a:solidFill>
               </a:rPr>
-              <a:t>   Combining various treatment modalities, such as transarterial chemoembolization with immune checkpoint inhibitors, shows potential in improving outcomes for patients with unresectable HCC.</a:t>
+              <a:t>   The combination of various treatment modalities, such as transarterial chemoembolization (TACE) with immune inhibitors, indicates a shift towards more comprehensive treatment approaches for unresectable HCC.</a:t>
             </a:r>
             <a:endParaRPr lang="en-US" sz="1200" dirty="0"/>
           </a:p>
@@ -3969,7 +3993,7 @@
                   <a:srgbClr val="FFFFFF"/>
                 </a:solidFill>
               </a:rPr>
-              <a:t>結合多種治療方式，如經動脈化療栓塞與免疫檢查點抑制劑，顯示出改善不可切除HCC患者預後的潛力。</a:t>
+              <a:t>將各種治療模式結合使用（如將經動脈化療栓塞（TACE）與免疫抑制劑結合）表明了對無法切除的HCC採取更全面治療方法的趨勢。</a:t>
             </a:r>
             <a:endParaRPr lang="en-US" sz="1200" dirty="0"/>
           </a:p>
@@ -4021,7 +4045,7 @@
                   <a:srgbClr val="FFFFFF"/>
                 </a:solidFill>
               </a:rPr>
-              <a:t>1. **早期階段的免疫療法應用**  </a:t>
+              <a:t>1. **早期免疫治療的優化**  </a:t>
             </a:r>
             <a:endParaRPr lang="en-US" sz="1200" dirty="0"/>
           </a:p>
@@ -4038,7 +4062,7 @@
                   <a:srgbClr val="FFFFFF"/>
                 </a:solidFill>
               </a:rPr>
-              <a:t>   Investigate optimal strategies for integrating immunotherapy in earlier stages of HCC to improve patient outcomes.  </a:t>
+              <a:t>   Future studies should focus on optimizing the timing and combination of immune therapies in early-stage HCC to maximize treatment efficacy.  </a:t>
             </a:r>
             <a:endParaRPr lang="en-US" sz="1200" dirty="0"/>
           </a:p>
@@ -4055,7 +4079,7 @@
                   <a:srgbClr val="FFFFFF"/>
                 </a:solidFill>
               </a:rPr>
-              <a:t>   探討在HCC早期階段整合免疫療法的最佳策略，以改善患者預後。</a:t>
+              <a:t>   未來的研究應集中於優化早期HCC中免疫治療的時機和組合，以最大化治療效果。</a:t>
             </a:r>
             <a:endParaRPr lang="en-US" sz="1200" dirty="0"/>
           </a:p>
@@ -4081,7 +4105,7 @@
                   <a:srgbClr val="FFFFFF"/>
                 </a:solidFill>
               </a:rPr>
-              <a:t>2. **腫瘤微環境的深入研究**  </a:t>
+              <a:t>2. **癌症相關成纖維細胞的靶向治療**  </a:t>
             </a:r>
             <a:endParaRPr lang="en-US" sz="1200" dirty="0"/>
           </a:p>
@@ -4098,7 +4122,7 @@
                   <a:srgbClr val="FFFFFF"/>
                 </a:solidFill>
               </a:rPr>
-              <a:t>   Further explore the mechanisms by which the tumor microenvironment influences immune response and therapy resistance in HCC.  </a:t>
+              <a:t>   Investigating targeted therapies against CAFs and their metabolic pathways may provide new avenues for enhancing anti-tumor immunity in HCC.  </a:t>
             </a:r>
             <a:endParaRPr lang="en-US" sz="1200" dirty="0"/>
           </a:p>
@@ -4115,7 +4139,7 @@
                   <a:srgbClr val="FFFFFF"/>
                 </a:solidFill>
               </a:rPr>
-              <a:t>   進一步研究腫瘤微環境如何影響HCC中的免疫反應和療法抵抗的機制。</a:t>
+              <a:t>   研究針對CAFs及其代謝途徑的靶向療法可能為增強HCC中的抗腫瘤免疫提供新的途徑。</a:t>
             </a:r>
             <a:endParaRPr lang="en-US" sz="1200" dirty="0"/>
           </a:p>
@@ -4141,7 +4165,7 @@
                   <a:srgbClr val="FFFFFF"/>
                 </a:solidFill>
               </a:rPr>
-              <a:t>3. **CAFs的代謝調控**  </a:t>
+              <a:t>3. **多模式療法的臨床試驗**  </a:t>
             </a:r>
             <a:endParaRPr lang="en-US" sz="1200" dirty="0"/>
           </a:p>
@@ -4158,7 +4182,7 @@
                   <a:srgbClr val="FFFFFF"/>
                 </a:solidFill>
               </a:rPr>
-              <a:t>   Elucidate the metabolic pathways of cancer-associated fibroblasts and their impact on immunosuppression to identify new therapeutic targets.  </a:t>
+              <a:t>   Conducting clinical trials that evaluate the efficacy of combined therapies, including immune checkpoint inhibitors and local ablation techniques, is essential for establishing best practices.  </a:t>
             </a:r>
             <a:endParaRPr lang="en-US" sz="1200" dirty="0"/>
           </a:p>
@@ -4175,7 +4199,7 @@
                   <a:srgbClr val="FFFFFF"/>
                 </a:solidFill>
               </a:rPr>
-              <a:t>   阐明癌症相關成纖維細胞的代謝途徑及其對免疫抑制的影響，以識別新的治療靶點。</a:t>
+              <a:t>   開展評估包括免疫檢查點抑制劑和局部消融技術的聯合療法有效性的臨床試驗對於建立最佳實踐至關重要。</a:t>
             </a:r>
             <a:endParaRPr lang="en-US" sz="1200" dirty="0"/>
           </a:p>
@@ -4201,7 +4225,7 @@
                   <a:srgbClr val="FFFFFF"/>
                 </a:solidFill>
               </a:rPr>
-              <a:t>4. **多模式治療的臨床試驗**  </a:t>
+              <a:t>4. **腫瘤微環境的深入研究**  </a:t>
             </a:r>
             <a:endParaRPr lang="en-US" sz="1200" dirty="0"/>
           </a:p>
@@ -4218,7 +4242,7 @@
                   <a:srgbClr val="FFFFFF"/>
                 </a:solidFill>
               </a:rPr>
-              <a:t>   Conduct clinical trials to evaluate the efficacy and safety of combination therapies involving immunotherapy and local ablative techniques for HCC.  </a:t>
+              <a:t>   Further research into the tumor microenvironment and its interactions with immune cells can unveil new therapeutic targets and strategies for HCC treatment.  </a:t>
             </a:r>
             <a:endParaRPr lang="en-US" sz="1200" dirty="0"/>
           </a:p>
@@ -4235,7 +4259,7 @@
                   <a:srgbClr val="FFFFFF"/>
                 </a:solidFill>
               </a:rPr>
-              <a:t>   進行臨床試驗以評估結合免疫療法和局部消融技術的療效和安全性。</a:t>
+              <a:t>   對腫瘤微環境及其與免疫細胞的相互作用的深入研究可以揭示HCC治療的新療法靶點和策略。</a:t>
             </a:r>
             <a:endParaRPr lang="en-US" sz="1200" dirty="0"/>
           </a:p>
@@ -4261,7 +4285,7 @@
                   <a:srgbClr val="FFFFFF"/>
                 </a:solidFill>
               </a:rPr>
-              <a:t>5. **術後復發的預防策略**  </a:t>
+              <a:t>5. **長期療效與耐藥性研究**  </a:t>
             </a:r>
             <a:endParaRPr lang="en-US" sz="1200" dirty="0"/>
           </a:p>
@@ -4278,7 +4302,7 @@
                   <a:srgbClr val="FFFFFF"/>
                 </a:solidFill>
               </a:rPr>
-              <a:t>   Develop and test strategies to prevent postoperative recurrence in HCC patients, focusing on adjuvant therapies that enhance immune response.  </a:t>
+              <a:t>   Investigating the long-term effects and potential resistance mechanisms associated with current immunotherapies will be crucial for improving patient outcomes in HCC.  </a:t>
             </a:r>
             <a:endParaRPr lang="en-US" sz="1200" dirty="0"/>
           </a:p>
@@ -4295,7 +4319,7 @@
                   <a:srgbClr val="FFFFFF"/>
                 </a:solidFill>
               </a:rPr>
-              <a:t>   開發和測試預防HCC患者術後復發的策略，重點在於增強免疫反應的輔助療法。</a:t>
+              <a:t>   研究目前免疫療法的長期效果及潛在的耐藥機制對於改善HCC患者的預後至關重要。</a:t>
             </a:r>
             <a:endParaRPr lang="en-US" sz="1200" dirty="0"/>
           </a:p>
@@ -5180,7 +5204,7 @@
                 <a:ea typeface="Arial" pitchFamily="34" charset="-122"/>
                 <a:cs typeface="Arial" pitchFamily="34" charset="-120"/>
               </a:rPr>
-              <a:t>Precision oncology targets iCCA mutations.</a:t>
+              <a:t>Precision oncology benefits iCCA patients.</a:t>
             </a:r>
             <a:endParaRPr lang="en-US" sz="1800" dirty="0"/>
           </a:p>
@@ -5188,7 +5212,43 @@
       </p:sp>
       <p:sp>
         <p:nvSpPr>
-          <p:cNvPr id="7" name="Text 5">
+          <p:cNvPr id="7" name="Text 5"/>
+          <p:cNvSpPr/>
+          <p:nvPr/>
+        </p:nvSpPr>
+        <p:spPr>
+          <a:xfrm>
+            <a:off x="731520" y="5852160"/>
+            <a:ext cx="10058400" cy="0"/>
+          </a:xfrm>
+          <a:prstGeom prst="rect">
+            <a:avLst/>
+          </a:prstGeom>
+          <a:noFill/>
+          <a:ln/>
+        </p:spPr>
+        <p:txBody>
+          <a:bodyPr wrap="square" lIns="0" tIns="0" rIns="0" bIns="0" rtlCol="0" anchor="ctr"/>
+          <a:lstStyle/>
+          <a:p>
+            <a:pPr indent="0" marL="0">
+              <a:buNone/>
+            </a:pPr>
+            <a:r>
+              <a:rPr lang="en-US" sz="800" dirty="0">
+                <a:solidFill>
+                  <a:srgbClr val="888888"/>
+                </a:solidFill>
+              </a:rPr>
+              <a:t>Llovet Josep M, Pinyol Roser, Affo Silvia et al.. Cell. 2026-04-17 DOI: 10.1016/j.cell.2026.03.001</a:t>
+            </a:r>
+            <a:endParaRPr lang="en-US" sz="800" dirty="0"/>
+          </a:p>
+        </p:txBody>
+      </p:sp>
+      <p:sp>
+        <p:nvSpPr>
+          <p:cNvPr id="8" name="Text 6">
             <a:hlinkClick r:id="rId2" tooltip=""/>
           </p:cNvPr>
           <p:cNvSpPr/>
@@ -5459,7 +5519,7 @@
                 <a:ea typeface="Arial" pitchFamily="34" charset="-122"/>
                 <a:cs typeface="Arial" pitchFamily="34" charset="-120"/>
               </a:rPr>
-              <a:t>Neoadjuvant SBRT combined with immune therapy</a:t>
+              <a:t>Neoadjuvant SBRT plus immune therapy tested</a:t>
             </a:r>
             <a:endParaRPr lang="en-US" sz="1800" dirty="0"/>
           </a:p>
@@ -5480,7 +5540,7 @@
                 <a:ea typeface="Arial" pitchFamily="34" charset="-122"/>
                 <a:cs typeface="Arial" pitchFamily="34" charset="-120"/>
               </a:rPr>
-              <a:t>Pilot study with 8 patients, safety assessed</a:t>
+              <a:t>Pilot study with 8 patients conducted</a:t>
             </a:r>
             <a:endParaRPr lang="en-US" sz="1800" dirty="0"/>
           </a:p>
@@ -5501,7 +5561,7 @@
                 <a:ea typeface="Arial" pitchFamily="34" charset="-122"/>
                 <a:cs typeface="Arial" pitchFamily="34" charset="-120"/>
               </a:rPr>
-              <a:t>One patient had grade 3 treatment-related adverse event</a:t>
+              <a:t>Safety endpoint: low grade 3-4 trAE</a:t>
             </a:r>
             <a:endParaRPr lang="en-US" sz="1800" dirty="0"/>
           </a:p>
@@ -5522,7 +5582,7 @@
                 <a:ea typeface="Arial" pitchFamily="34" charset="-122"/>
                 <a:cs typeface="Arial" pitchFamily="34" charset="-120"/>
               </a:rPr>
-              <a:t>All resected patients achieved R0 resection</a:t>
+              <a:t>All resected patients relapse-free</a:t>
             </a:r>
             <a:endParaRPr lang="en-US" sz="1800" dirty="0"/>
           </a:p>
@@ -5543,7 +5603,7 @@
                 <a:ea typeface="Arial" pitchFamily="34" charset="-122"/>
                 <a:cs typeface="Arial" pitchFamily="34" charset="-120"/>
               </a:rPr>
-              <a:t>Increased immune infiltration post-treatment observed</a:t>
+              <a:t>Enhanced anti-cancer immune infiltration observed</a:t>
             </a:r>
             <a:endParaRPr lang="en-US" sz="1800" dirty="0"/>
           </a:p>
@@ -5551,7 +5611,43 @@
       </p:sp>
       <p:sp>
         <p:nvSpPr>
-          <p:cNvPr id="7" name="Text 5">
+          <p:cNvPr id="7" name="Text 5"/>
+          <p:cNvSpPr/>
+          <p:nvPr/>
+        </p:nvSpPr>
+        <p:spPr>
+          <a:xfrm>
+            <a:off x="731520" y="5852160"/>
+            <a:ext cx="10058400" cy="0"/>
+          </a:xfrm>
+          <a:prstGeom prst="rect">
+            <a:avLst/>
+          </a:prstGeom>
+          <a:noFill/>
+          <a:ln/>
+        </p:spPr>
+        <p:txBody>
+          <a:bodyPr wrap="square" lIns="0" tIns="0" rIns="0" bIns="0" rtlCol="0" anchor="ctr"/>
+          <a:lstStyle/>
+          <a:p>
+            <a:pPr indent="0" marL="0">
+              <a:buNone/>
+            </a:pPr>
+            <a:r>
+              <a:rPr lang="en-US" sz="800" dirty="0">
+                <a:solidFill>
+                  <a:srgbClr val="888888"/>
+                </a:solidFill>
+              </a:rPr>
+              <a:t>Cosner Zoe, Guo Zhoubo, Nawrocki Cole et al.. Clinical cancer research : an official journal of the American Association for Cancer Research. 2026-04-15 DOI: 10.1158/1078-0432.CCR-25-4779</a:t>
+            </a:r>
+            <a:endParaRPr lang="en-US" sz="800" dirty="0"/>
+          </a:p>
+        </p:txBody>
+      </p:sp>
+      <p:sp>
+        <p:nvSpPr>
+          <p:cNvPr id="8" name="Text 6">
             <a:hlinkClick r:id="rId2" tooltip=""/>
           </p:cNvPr>
           <p:cNvSpPr/>
@@ -5843,7 +5939,7 @@
                 <a:ea typeface="Arial" pitchFamily="34" charset="-122"/>
                 <a:cs typeface="Arial" pitchFamily="34" charset="-120"/>
               </a:rPr>
-              <a:t>Neoadjuvant efficacy remains intact</a:t>
+              <a:t>Mouse model used for study</a:t>
             </a:r>
             <a:endParaRPr lang="en-US" sz="1800" dirty="0"/>
           </a:p>
@@ -5864,7 +5960,7 @@
                 <a:ea typeface="Arial" pitchFamily="34" charset="-122"/>
                 <a:cs typeface="Arial" pitchFamily="34" charset="-120"/>
               </a:rPr>
-              <a:t>Mouse model used for study</a:t>
+              <a:t>Neoadjuvant efficacy remains intact</a:t>
             </a:r>
             <a:endParaRPr lang="en-US" sz="1800" dirty="0"/>
           </a:p>
@@ -5872,7 +5968,43 @@
       </p:sp>
       <p:sp>
         <p:nvSpPr>
-          <p:cNvPr id="7" name="Text 5">
+          <p:cNvPr id="7" name="Text 5"/>
+          <p:cNvSpPr/>
+          <p:nvPr/>
+        </p:nvSpPr>
+        <p:spPr>
+          <a:xfrm>
+            <a:off x="731520" y="5852160"/>
+            <a:ext cx="10058400" cy="0"/>
+          </a:xfrm>
+          <a:prstGeom prst="rect">
+            <a:avLst/>
+          </a:prstGeom>
+          <a:noFill/>
+          <a:ln/>
+        </p:spPr>
+        <p:txBody>
+          <a:bodyPr wrap="square" lIns="0" tIns="0" rIns="0" bIns="0" rtlCol="0" anchor="ctr"/>
+          <a:lstStyle/>
+          <a:p>
+            <a:pPr indent="0" marL="0">
+              <a:buNone/>
+            </a:pPr>
+            <a:r>
+              <a:rPr lang="en-US" sz="800" dirty="0">
+                <a:solidFill>
+                  <a:srgbClr val="888888"/>
+                </a:solidFill>
+              </a:rPr>
+              <a:t>Bouguerra Roqiya, El Hajji Sofia, Wassmer Charles-Henri et al.. Hepatology (Baltimore, Md.). 2026-04-16 DOI: 10.1097/HEP.0000000000001731</a:t>
+            </a:r>
+            <a:endParaRPr lang="en-US" sz="800" dirty="0"/>
+          </a:p>
+        </p:txBody>
+      </p:sp>
+      <p:sp>
+        <p:nvSpPr>
+          <p:cNvPr id="8" name="Text 6">
             <a:hlinkClick r:id="rId2" tooltip=""/>
           </p:cNvPr>
           <p:cNvSpPr/>
@@ -6143,7 +6275,7 @@
                 <a:ea typeface="Arial" pitchFamily="34" charset="-122"/>
                 <a:cs typeface="Arial" pitchFamily="34" charset="-120"/>
               </a:rPr>
-              <a:t>Lactobacillus johnsonii enriches IFNγ+PD-1+CD8+ T cells.</a:t>
+              <a:t>Lactobacillus johnsonii enhances CD8+ T-cell expansion.</a:t>
             </a:r>
             <a:endParaRPr lang="en-US" sz="1800" dirty="0"/>
           </a:p>
@@ -6164,7 +6296,7 @@
                 <a:ea typeface="Arial" pitchFamily="34" charset="-122"/>
                 <a:cs typeface="Arial" pitchFamily="34" charset="-120"/>
               </a:rPr>
-              <a:t>Nicotinic acid enhances T-cell expansion and function.</a:t>
+              <a:t>Higher Lactobacillus correlates with disease-free survival.</a:t>
             </a:r>
             <a:endParaRPr lang="en-US" sz="1800" dirty="0"/>
           </a:p>
@@ -6185,15 +6317,93 @@
                 <a:ea typeface="Arial" pitchFamily="34" charset="-122"/>
                 <a:cs typeface="Arial" pitchFamily="34" charset="-120"/>
               </a:rPr>
-              <a:t>L. johnsonii activates NF-κB pathway for immune response.</a:t>
+              <a:t>Nicotinic acid activates NF-κB pathway in T cells.</a:t>
             </a:r>
             <a:endParaRPr lang="en-US" sz="1800" dirty="0"/>
           </a:p>
-        </p:txBody>
-      </p:sp>
-      <p:sp>
-        <p:nvSpPr>
-          <p:cNvPr id="7" name="Text 5">
+          <a:p>
+            <a:pPr marL="342900" indent="-342900">
+              <a:spcAft>
+                <a:spcPts val="800"/>
+              </a:spcAft>
+              <a:buSzPct val="100000"/>
+              <a:buChar char="•"/>
+            </a:pPr>
+            <a:r>
+              <a:rPr lang="en-US" sz="1800" dirty="0">
+                <a:solidFill>
+                  <a:srgbClr val="333333"/>
+                </a:solidFill>
+                <a:latin typeface="Arial" pitchFamily="34" charset="0"/>
+                <a:ea typeface="Arial" pitchFamily="34" charset="-122"/>
+                <a:cs typeface="Arial" pitchFamily="34" charset="-120"/>
+              </a:rPr>
+              <a:t>Combination therapy reduces tumor relapse effectively.</a:t>
+            </a:r>
+            <a:endParaRPr lang="en-US" sz="1800" dirty="0"/>
+          </a:p>
+          <a:p>
+            <a:pPr marL="342900" indent="-342900">
+              <a:spcAft>
+                <a:spcPts val="800"/>
+              </a:spcAft>
+              <a:buSzPct val="100000"/>
+              <a:buChar char="•"/>
+            </a:pPr>
+            <a:r>
+              <a:rPr lang="en-US" sz="1800" dirty="0">
+                <a:solidFill>
+                  <a:srgbClr val="333333"/>
+                </a:solidFill>
+                <a:latin typeface="Arial" pitchFamily="34" charset="0"/>
+                <a:ea typeface="Arial" pitchFamily="34" charset="-122"/>
+                <a:cs typeface="Arial" pitchFamily="34" charset="-120"/>
+              </a:rPr>
+              <a:t>CD8+ T cells are essential for antitumor efficacy.</a:t>
+            </a:r>
+            <a:endParaRPr lang="en-US" sz="1800" dirty="0"/>
+          </a:p>
+        </p:txBody>
+      </p:sp>
+      <p:sp>
+        <p:nvSpPr>
+          <p:cNvPr id="7" name="Text 5"/>
+          <p:cNvSpPr/>
+          <p:nvPr/>
+        </p:nvSpPr>
+        <p:spPr>
+          <a:xfrm>
+            <a:off x="731520" y="5852160"/>
+            <a:ext cx="10058400" cy="0"/>
+          </a:xfrm>
+          <a:prstGeom prst="rect">
+            <a:avLst/>
+          </a:prstGeom>
+          <a:noFill/>
+          <a:ln/>
+        </p:spPr>
+        <p:txBody>
+          <a:bodyPr wrap="square" lIns="0" tIns="0" rIns="0" bIns="0" rtlCol="0" anchor="ctr"/>
+          <a:lstStyle/>
+          <a:p>
+            <a:pPr indent="0" marL="0">
+              <a:buNone/>
+            </a:pPr>
+            <a:r>
+              <a:rPr lang="en-US" sz="800" dirty="0">
+                <a:solidFill>
+                  <a:srgbClr val="888888"/>
+                </a:solidFill>
+              </a:rPr>
+              <a:t>Liu Qianshi, Liu Yiqiang, Zhou Yue et al.. Cancer research. 2026-04-15 DOI: 10.1158/0008-5472.CAN-25-0346</a:t>
+            </a:r>
+            <a:endParaRPr lang="en-US" sz="800" dirty="0"/>
+          </a:p>
+        </p:txBody>
+      </p:sp>
+      <p:sp>
+        <p:nvSpPr>
+          <p:cNvPr id="8" name="Text 6">
             <a:hlinkClick r:id="rId2" tooltip=""/>
           </p:cNvPr>
           <p:cNvSpPr/>
@@ -6506,7 +6716,7 @@
                 <a:ea typeface="Arial" pitchFamily="34" charset="-122"/>
                 <a:cs typeface="Arial" pitchFamily="34" charset="-120"/>
               </a:rPr>
-              <a:t>ANGPTL4 enhances PD-L1 expression.</a:t>
+              <a:t>ANGPTL4 enhances immune evasion via PD-L1.</a:t>
             </a:r>
             <a:endParaRPr lang="en-US" sz="1800" dirty="0"/>
           </a:p>
@@ -6548,7 +6758,7 @@
                 <a:ea typeface="Arial" pitchFamily="34" charset="-122"/>
                 <a:cs typeface="Arial" pitchFamily="34" charset="-120"/>
               </a:rPr>
-              <a:t>Therapy synergizes with anti-PD-L1 treatment.</a:t>
+              <a:t>Therapeutic strategy for HCC immunotherapy.</a:t>
             </a:r>
             <a:endParaRPr lang="en-US" sz="1800" dirty="0"/>
           </a:p>
@@ -6556,7 +6766,43 @@
       </p:sp>
       <p:sp>
         <p:nvSpPr>
-          <p:cNvPr id="7" name="Text 5">
+          <p:cNvPr id="7" name="Text 5"/>
+          <p:cNvSpPr/>
+          <p:nvPr/>
+        </p:nvSpPr>
+        <p:spPr>
+          <a:xfrm>
+            <a:off x="731520" y="5852160"/>
+            <a:ext cx="10058400" cy="0"/>
+          </a:xfrm>
+          <a:prstGeom prst="rect">
+            <a:avLst/>
+          </a:prstGeom>
+          <a:noFill/>
+          <a:ln/>
+        </p:spPr>
+        <p:txBody>
+          <a:bodyPr wrap="square" lIns="0" tIns="0" rIns="0" bIns="0" rtlCol="0" anchor="ctr"/>
+          <a:lstStyle/>
+          <a:p>
+            <a:pPr indent="0" marL="0">
+              <a:buNone/>
+            </a:pPr>
+            <a:r>
+              <a:rPr lang="en-US" sz="800" dirty="0">
+                <a:solidFill>
+                  <a:srgbClr val="888888"/>
+                </a:solidFill>
+              </a:rPr>
+              <a:t>Lu Shounan, Ke Shanjia, Yu Hongjun et al.. Advanced science (Weinheim, Baden-Wurttemberg, Germany). 2026-04-14 DOI: 10.1002/advs.202521418</a:t>
+            </a:r>
+            <a:endParaRPr lang="en-US" sz="800" dirty="0"/>
+          </a:p>
+        </p:txBody>
+      </p:sp>
+      <p:sp>
+        <p:nvSpPr>
+          <p:cNvPr id="8" name="Text 6">
             <a:hlinkClick r:id="rId2" tooltip=""/>
           </p:cNvPr>
           <p:cNvSpPr/>
@@ -6848,7 +7094,7 @@
                 <a:ea typeface="Arial" pitchFamily="34" charset="-122"/>
                 <a:cs typeface="Arial" pitchFamily="34" charset="-120"/>
               </a:rPr>
-              <a:t>Depletion of virus-specific CD8 T cells observed.</a:t>
+              <a:t>Depletion of PD-1+ CD8 T cells observed.</a:t>
             </a:r>
             <a:endParaRPr lang="en-US" sz="1800" dirty="0"/>
           </a:p>
@@ -6869,7 +7115,7 @@
                 <a:ea typeface="Arial" pitchFamily="34" charset="-122"/>
                 <a:cs typeface="Arial" pitchFamily="34" charset="-120"/>
               </a:rPr>
-              <a:t>Activating FcγR III mediates T cell depletion.</a:t>
+              <a:t>FcγR III mediates T cell depletion.</a:t>
             </a:r>
             <a:endParaRPr lang="en-US" sz="1800" dirty="0"/>
           </a:p>
@@ -6890,7 +7136,7 @@
                 <a:ea typeface="Arial" pitchFamily="34" charset="-122"/>
                 <a:cs typeface="Arial" pitchFamily="34" charset="-120"/>
               </a:rPr>
-              <a:t>Phagocytic cells are key effectors in vivo.</a:t>
+              <a:t>Phagocytic cells are key effectors.</a:t>
             </a:r>
             <a:endParaRPr lang="en-US" sz="1800" dirty="0"/>
           </a:p>
@@ -6911,7 +7157,7 @@
                 <a:ea typeface="Arial" pitchFamily="34" charset="-122"/>
                 <a:cs typeface="Arial" pitchFamily="34" charset="-120"/>
               </a:rPr>
-              <a:t>Fc-intact antibodies may hinder liver cancer treatment.</a:t>
+              <a:t>Findings affect liver cancer treatment strategies.</a:t>
             </a:r>
             <a:endParaRPr lang="en-US" sz="1800" dirty="0"/>
           </a:p>
@@ -6919,7 +7165,43 @@
       </p:sp>
       <p:sp>
         <p:nvSpPr>
-          <p:cNvPr id="7" name="Text 5">
+          <p:cNvPr id="7" name="Text 5"/>
+          <p:cNvSpPr/>
+          <p:nvPr/>
+        </p:nvSpPr>
+        <p:spPr>
+          <a:xfrm>
+            <a:off x="731520" y="5852160"/>
+            <a:ext cx="10058400" cy="0"/>
+          </a:xfrm>
+          <a:prstGeom prst="rect">
+            <a:avLst/>
+          </a:prstGeom>
+          <a:noFill/>
+          <a:ln/>
+        </p:spPr>
+        <p:txBody>
+          <a:bodyPr wrap="square" lIns="0" tIns="0" rIns="0" bIns="0" rtlCol="0" anchor="ctr"/>
+          <a:lstStyle/>
+          <a:p>
+            <a:pPr indent="0" marL="0">
+              <a:buNone/>
+            </a:pPr>
+            <a:r>
+              <a:rPr lang="en-US" sz="800" dirty="0">
+                <a:solidFill>
+                  <a:srgbClr val="888888"/>
+                </a:solidFill>
+              </a:rPr>
+              <a:t>Hashimoto Masao, Nasti Tahseen H, Jin Hyun-Tak et al.. Proceedings of the National Academy of Sciences of the United States of America. 2026-04-08 DOI: 10.1073/pnas.2427192123</a:t>
+            </a:r>
+            <a:endParaRPr lang="en-US" sz="800" dirty="0"/>
+          </a:p>
+        </p:txBody>
+      </p:sp>
+      <p:sp>
+        <p:nvSpPr>
+          <p:cNvPr id="8" name="Text 6">
             <a:hlinkClick r:id="rId2" tooltip=""/>
           </p:cNvPr>
           <p:cNvSpPr/>
@@ -7232,7 +7514,7 @@
                 <a:ea typeface="Arial" pitchFamily="34" charset="-122"/>
                 <a:cs typeface="Arial" pitchFamily="34" charset="-120"/>
               </a:rPr>
-              <a:t>Improved outcomes compared to monotherapy</a:t>
+              <a:t>Improved outcomes compared to standard therapy</a:t>
             </a:r>
             <a:endParaRPr lang="en-US" sz="1800" dirty="0"/>
           </a:p>
@@ -7274,7 +7556,7 @@
                 <a:ea typeface="Arial" pitchFamily="34" charset="-122"/>
                 <a:cs typeface="Arial" pitchFamily="34" charset="-120"/>
               </a:rPr>
-              <a:t>Addressing poor prognosis in HCC</a:t>
+              <a:t>Potential shift in treatment paradigms</a:t>
             </a:r>
             <a:endParaRPr lang="en-US" sz="1800" dirty="0"/>
           </a:p>
@@ -7282,7 +7564,43 @@
       </p:sp>
       <p:sp>
         <p:nvSpPr>
-          <p:cNvPr id="7" name="Text 5">
+          <p:cNvPr id="7" name="Text 5"/>
+          <p:cNvSpPr/>
+          <p:nvPr/>
+        </p:nvSpPr>
+        <p:spPr>
+          <a:xfrm>
+            <a:off x="731520" y="5852160"/>
+            <a:ext cx="10058400" cy="0"/>
+          </a:xfrm>
+          <a:prstGeom prst="rect">
+            <a:avLst/>
+          </a:prstGeom>
+          <a:noFill/>
+          <a:ln/>
+        </p:spPr>
+        <p:txBody>
+          <a:bodyPr wrap="square" lIns="0" tIns="0" rIns="0" bIns="0" rtlCol="0" anchor="ctr"/>
+          <a:lstStyle/>
+          <a:p>
+            <a:pPr indent="0" marL="0">
+              <a:buNone/>
+            </a:pPr>
+            <a:r>
+              <a:rPr lang="en-US" sz="800" dirty="0">
+                <a:solidFill>
+                  <a:srgbClr val="888888"/>
+                </a:solidFill>
+              </a:rPr>
+              <a:t>L Marzi, R Sacco, L Siciliani. …. 2026</a:t>
+            </a:r>
+            <a:endParaRPr lang="en-US" sz="800" dirty="0"/>
+          </a:p>
+        </p:txBody>
+      </p:sp>
+      <p:sp>
+        <p:nvSpPr>
+          <p:cNvPr id="8" name="Text 6">
             <a:hlinkClick r:id="rId2" tooltip=""/>
           </p:cNvPr>
           <p:cNvSpPr/>

</xml_diff>

<commit_message>
chore: update weekly digest 2026-09-07
</commit_message>
<xml_diff>
--- a/docs/digest-en.pptx
+++ b/docs/digest-en.pptx
@@ -2269,7 +2269,7 @@
                   <a:srgbClr val="888888"/>
                 </a:solidFill>
               </a:rPr>
-              <a:t>2026-08-24 — 2026-08-31</a:t>
+              <a:t>2026-08-31 — 2026-09-07</a:t>
             </a:r>
             <a:endParaRPr lang="en-US" sz="1400" dirty="0"/>
           </a:p>
@@ -2460,7 +2460,7 @@
                   </a:extLst>
                 </a:hlinkClick>
               </a:rPr>
-              <a:t>Cryoablation versus radiofrequency ablation for hepatocellular carcinoma: a systematic review and meta-analysis</a:t>
+              <a:t>Perioperative tislelizumab for early-stage hepatocellular carcinoma: A phase II trial with integrated tumour microenvironment profiling and predictive modeling.</a:t>
             </a:r>
             <a:endParaRPr lang="en-US" sz="2400" dirty="0"/>
           </a:p>
@@ -2496,7 +2496,7 @@
                   <a:srgbClr val="888888"/>
                 </a:solidFill>
               </a:rPr>
-              <a:t>International Journal of …  ·  Meta-Analysis</a:t>
+              <a:t>Drug resistance updates : reviews and commentaries in antimicrobial and anticancer chemotherapy  ·  RCT Phase 2</a:t>
             </a:r>
             <a:endParaRPr lang="en-US" sz="1000" dirty="0"/>
           </a:p>
@@ -2575,7 +2575,7 @@
                   <a:srgbClr val="888888"/>
                 </a:solidFill>
               </a:rPr>
-              <a:t>K Mao, Y Wang, W Yao. International Journal of …. 2026</a:t>
+              <a:t>Chen Lu, Han Ruyu, Zhai Shujie et al.. Drug resistance updates : reviews and commentaries in antimicrobial and anticancer chemotherapy. 2026-07-23 DOI: 10.1016/j.drup.2026.101440</a:t>
             </a:r>
             <a:endParaRPr lang="en-US" sz="800" dirty="0"/>
           </a:p>
@@ -2775,7 +2775,7 @@
                   </a:extLst>
                 </a:hlinkClick>
               </a:rPr>
-              <a:t>External beam radiotherapy versus local ablation therapy for the treatment of hepatocellular carcinoma: a systematic review and meta-analysis</a:t>
+              <a:t>… plus transarterial chemoembolization and PD-1 inhibitors as conversion therapies for unresectable intermediate-advanced hepatocellular carcinoma: a phase 2 trial …</a:t>
             </a:r>
             <a:endParaRPr lang="en-US" sz="2400" dirty="0"/>
           </a:p>
@@ -2811,7 +2811,7 @@
                   <a:srgbClr val="888888"/>
                 </a:solidFill>
               </a:rPr>
-              <a:t>Clinical and Molecular …  ·  Meta-Analysis</a:t>
+              <a:t>… and Targeted Therapy  ·  RCT Phase 2</a:t>
             </a:r>
             <a:endParaRPr lang="en-US" sz="1000" dirty="0"/>
           </a:p>
@@ -2890,7 +2890,7 @@
                   <a:srgbClr val="888888"/>
                 </a:solidFill>
               </a:rPr>
-              <a:t>SH Bae, SH Choi, SM Yoon. Clinical and Molecular …</a:t>
+              <a:t>X Zhang, H Cai, W Peng. … and Targeted Therapy. 2026</a:t>
             </a:r>
             <a:endParaRPr lang="en-US" sz="800" dirty="0"/>
           </a:p>
@@ -3090,7 +3090,7 @@
                   </a:extLst>
                 </a:hlinkClick>
               </a:rPr>
-              <a:t>Defining the role of minimally invasive surgical thermal ablation in liver malignancies: A systematic review and meta-analysis of outcomes and reporting …</a:t>
+              <a:t>… (PD-1 inhibitor) plus lenvatinib as conversion therapy followed by sequential surgery (SILENSES) for advanced unresectable hepatocellular carcinoma: a phase II …</a:t>
             </a:r>
             <a:endParaRPr lang="en-US" sz="2400" dirty="0"/>
           </a:p>
@@ -3126,7 +3126,7 @@
                   <a:srgbClr val="888888"/>
                 </a:solidFill>
               </a:rPr>
-              <a:t>European Journal of …  ·  Meta-Analysis</a:t>
+              <a:t>… and Targeted Therapy  ·  RCT Phase 2</a:t>
             </a:r>
             <a:endParaRPr lang="en-US" sz="1000" dirty="0"/>
           </a:p>
@@ -3205,7 +3205,7 @@
                   <a:srgbClr val="888888"/>
                 </a:solidFill>
               </a:rPr>
-              <a:t>G Scotton, F Notte, HC Pommergaard…. European Journal of …. 2026</a:t>
+              <a:t>S Lu, W Zhang, J Li. … and Targeted Therapy. 2026</a:t>
             </a:r>
             <a:endParaRPr lang="en-US" sz="800" dirty="0"/>
           </a:p>
@@ -3776,7 +3776,7 @@
                 <a:ea typeface="Arial" pitchFamily="34" charset="-122"/>
                 <a:cs typeface="Arial" pitchFamily="34" charset="-120"/>
               </a:rPr>
-              <a:t>On-demand transarterial chemoembolisation combined with atezolizumab and bevaciz…</a:t>
+              <a:t>Durvalumab and tremelimumab, with or without lenvatinib, combined with transarte…</a:t>
             </a:r>
             <a:endParaRPr lang="en-US" sz="1400" dirty="0"/>
           </a:p>
@@ -3813,7 +3813,7 @@
                 <a:ea typeface="Arial" pitchFamily="34" charset="-122"/>
                 <a:cs typeface="Arial" pitchFamily="34" charset="-120"/>
               </a:rPr>
-              <a:t>Atezolizumab-Bevacizumab with or without Cisplatin-based HAIC for Unresectable H…</a:t>
+              <a:t>Perioperative strategies for the treatment of HCC.</a:t>
             </a:r>
             <a:endParaRPr lang="en-US" sz="1400" dirty="0"/>
           </a:p>
@@ -3850,7 +3850,7 @@
                 <a:ea typeface="Arial" pitchFamily="34" charset="-122"/>
                 <a:cs typeface="Arial" pitchFamily="34" charset="-120"/>
               </a:rPr>
-              <a:t>Phase 2 Study of Futibatinib in Combination with Pembrolizumab in Patients with …</a:t>
+              <a:t>A multicenter pilot study of nivolumab with drug-eluting bead transarterial chem…</a:t>
             </a:r>
             <a:endParaRPr lang="en-US" sz="1400" dirty="0"/>
           </a:p>
@@ -3887,7 +3887,7 @@
                 <a:ea typeface="Arial" pitchFamily="34" charset="-122"/>
                 <a:cs typeface="Arial" pitchFamily="34" charset="-120"/>
               </a:rPr>
-              <a:t>… plus transarterial chemoembolization and PD-1 inhibitors as conversion therapi…</a:t>
+              <a:t>Expanding the path to cure - a narrative review on optimizing multimodality sequ…</a:t>
             </a:r>
             <a:endParaRPr lang="en-US" sz="1400" dirty="0"/>
           </a:p>
@@ -3924,7 +3924,7 @@
                 <a:ea typeface="Arial" pitchFamily="34" charset="-122"/>
                 <a:cs typeface="Arial" pitchFamily="34" charset="-120"/>
               </a:rPr>
-              <a:t>… (PD-1 inhibitor) plus lenvatinib as conversion therapy followed by sequential …</a:t>
+              <a:t>Adaptive radiofrequency ablation using an Octopus multipurpose electrode for sma…</a:t>
             </a:r>
             <a:endParaRPr lang="en-US" sz="1400" dirty="0"/>
           </a:p>
@@ -3961,7 +3961,7 @@
                 <a:ea typeface="Arial" pitchFamily="34" charset="-122"/>
                 <a:cs typeface="Arial" pitchFamily="34" charset="-120"/>
               </a:rPr>
-              <a:t>Defect-Engineered BiO2-X Nanosheets Mediate Sono-Thermomechanical ECM Remodeling…</a:t>
+              <a:t>Clinical predictors of response to atezolizumab/bevacizumab in Child-Pugh B pati…</a:t>
             </a:r>
             <a:endParaRPr lang="en-US" sz="1400" dirty="0"/>
           </a:p>
@@ -3998,7 +3998,7 @@
                 <a:ea typeface="Arial" pitchFamily="34" charset="-122"/>
                 <a:cs typeface="Arial" pitchFamily="34" charset="-120"/>
               </a:rPr>
-              <a:t>Enhanced glucose uptake promotes the survival of hepatocellular carcinoma cells …</a:t>
+              <a:t>Spatiotemporal dynamics of the tumor microenvironment in hepatocellular carcinom…</a:t>
             </a:r>
             <a:endParaRPr lang="en-US" sz="1400" dirty="0"/>
           </a:p>
@@ -4035,7 +4035,7 @@
                 <a:ea typeface="Arial" pitchFamily="34" charset="-122"/>
                 <a:cs typeface="Arial" pitchFamily="34" charset="-120"/>
               </a:rPr>
-              <a:t>Cryoablation versus radiofrequency ablation for hepatocellular carcinoma: a syst…</a:t>
+              <a:t>Perioperative tislelizumab for early-stage hepatocellular carcinoma: A phase II …</a:t>
             </a:r>
             <a:endParaRPr lang="en-US" sz="1400" dirty="0"/>
           </a:p>
@@ -4072,7 +4072,7 @@
                 <a:ea typeface="Arial" pitchFamily="34" charset="-122"/>
                 <a:cs typeface="Arial" pitchFamily="34" charset="-120"/>
               </a:rPr>
-              <a:t>External beam radiotherapy versus local ablation therapy for the treatment of he…</a:t>
+              <a:t>… plus transarterial chemoembolization and PD-1 inhibitors as conversion therapi…</a:t>
             </a:r>
             <a:endParaRPr lang="en-US" sz="1400" dirty="0"/>
           </a:p>
@@ -4109,7 +4109,7 @@
                 <a:ea typeface="Arial" pitchFamily="34" charset="-122"/>
                 <a:cs typeface="Arial" pitchFamily="34" charset="-120"/>
               </a:rPr>
-              <a:t>Defining the role of minimally invasive surgical thermal ablation in liver malig…</a:t>
+              <a:t>… (PD-1 inhibitor) plus lenvatinib as conversion therapy followed by sequential …</a:t>
             </a:r>
             <a:endParaRPr lang="en-US" sz="1400" dirty="0"/>
           </a:p>
@@ -4264,7 +4264,7 @@
                   </a:extLst>
                 </a:hlinkClick>
               </a:rPr>
-              <a:t>On-demand transarterial chemoembolisation combined with atezolizumab and bevacizumab in patients with untreated hepatocellular carcinoma (TALENTACE): a multicentre, randomised, open-label, phase 3 trial.</a:t>
+              <a:t>Durvalumab and tremelimumab, with or without lenvatinib, combined with transarterial chemoembolisation in participants with embolisation-eligible hepatocellular carcinoma (EMERALD-3): a global, randomised, open-label, sponsor-blinded, phase 3 study.</a:t>
             </a:r>
             <a:endParaRPr lang="en-US" sz="2400" dirty="0"/>
           </a:p>
@@ -4300,7 +4300,7 @@
                   <a:srgbClr val="888888"/>
                 </a:solidFill>
               </a:rPr>
-              <a:t>The lancet. Gastroenterology &amp; hepatology  ·  IF 35.7  ·  RCT Phase 3  ·  🌏 Asia</a:t>
+              <a:t>The Lancet. Oncology  ·  IF 41.6  ·  RCT Phase 3  ·  🌏 Asia</a:t>
             </a:r>
             <a:endParaRPr lang="en-US" sz="1000" dirty="0"/>
           </a:p>
@@ -4379,7 +4379,7 @@
                   <a:srgbClr val="888888"/>
                 </a:solidFill>
               </a:rPr>
-              <a:t>Kudo Masatoshi, Ogasawara Sadahisa, Liu Ruibao et al.. The lancet. Gastroenterology &amp; hepatology. 2026-08-25 DOI: 10.1016/S2468-1253(26)00212-8</a:t>
+              <a:t>Kudo Masatoshi, Abou-Alfa Ghassan K, Ren Zhenggang et al.. The Lancet. Oncology. 2026-08-24 DOI: 10.1016/S1470-2045(26)00278-0</a:t>
             </a:r>
             <a:endParaRPr lang="en-US" sz="800" dirty="0"/>
           </a:p>
@@ -4579,7 +4579,7 @@
                   </a:extLst>
                 </a:hlinkClick>
               </a:rPr>
-              <a:t>Atezolizumab-Bevacizumab with or without Cisplatin-based HAIC for Unresectable HCC: A Randomized Phase 2 Trial.</a:t>
+              <a:t>Perioperative strategies for the treatment of HCC.</a:t>
             </a:r>
             <a:endParaRPr lang="en-US" sz="2400" dirty="0"/>
           </a:p>
@@ -4615,7 +4615,7 @@
                   <a:srgbClr val="888888"/>
                 </a:solidFill>
               </a:rPr>
-              <a:t>JHEP reports : innovation in hepatology  ·  IF 7.8  ·  RCT Phase 3  ·  🌏 Asia</a:t>
+              <a:t>JHEP reports : innovation in hepatology  ·  IF 7.8  ·  RCT Phase 2</a:t>
             </a:r>
             <a:endParaRPr lang="en-US" sz="1000" dirty="0"/>
           </a:p>
@@ -4694,7 +4694,7 @@
                   <a:srgbClr val="888888"/>
                 </a:solidFill>
               </a:rPr>
-              <a:t>Takeuchi Yasuto, Sue Masahiko, Miyake Nozomi et al.. JHEP reports : innovation in hepatology. 2026-08-28 DOI: 10.1016/j.jhepr.2026.102002</a:t>
+              <a:t>D'Alessio Antonio, Krendl Felix J, Parente Alessandro et al.. JHEP reports : innovation in hepatology. 2026-09-03 DOI: 10.1016/j.jhepr.2026.102021</a:t>
             </a:r>
             <a:endParaRPr lang="en-US" sz="800" dirty="0"/>
           </a:p>
@@ -4894,7 +4894,7 @@
                   </a:extLst>
                 </a:hlinkClick>
               </a:rPr>
-              <a:t>Phase 2 Study of Futibatinib in Combination with Pembrolizumab in Patients with FGF19 expressing Advanced Hepatocellular Carcinoma.</a:t>
+              <a:t>A multicenter pilot study of nivolumab with drug-eluting bead transarterial chemoembolization in patients with liver-limited hepatocellular carcinoma.</a:t>
             </a:r>
             <a:endParaRPr lang="en-US" sz="2400" dirty="0"/>
           </a:p>
@@ -4930,7 +4930,7 @@
                   <a:srgbClr val="888888"/>
                 </a:solidFill>
               </a:rPr>
-              <a:t>The oncologist  ·  RCT Phase 2</a:t>
+              <a:t>ESMO gastrointestinal oncology  ·  RCT Phase 3</a:t>
             </a:r>
             <a:endParaRPr lang="en-US" sz="1000" dirty="0"/>
           </a:p>
@@ -5009,7 +5009,7 @@
                   <a:srgbClr val="888888"/>
                 </a:solidFill>
               </a:rPr>
-              <a:t>Tran Nguyen H, Palmer Mathias E, Ulrich Angela et al.. The oncologist. 2026-08-25 DOI: 10.1093/oncolo/oyag343</a:t>
+              <a:t>Harding J J, Fitzpatrick O M, Chou J F et al.. ESMO gastrointestinal oncology. 2026-08-28 DOI: 10.1016/j.esmogo.2026.100402</a:t>
             </a:r>
             <a:endParaRPr lang="en-US" sz="800" dirty="0"/>
           </a:p>
@@ -5209,7 +5209,7 @@
                   </a:extLst>
                 </a:hlinkClick>
               </a:rPr>
-              <a:t>… plus transarterial chemoembolization and PD-1 inhibitors as conversion therapies for unresectable intermediate-advanced hepatocellular carcinoma: a phase 2 trial …</a:t>
+              <a:t>Expanding the path to cure - a narrative review on optimizing multimodality sequencing in HCC.</a:t>
             </a:r>
             <a:endParaRPr lang="en-US" sz="2400" dirty="0"/>
           </a:p>
@@ -5245,7 +5245,7 @@
                   <a:srgbClr val="888888"/>
                 </a:solidFill>
               </a:rPr>
-              <a:t>… and Targeted Therapy  ·  RCT Phase 2</a:t>
+              <a:t>Cancer treatment reviews  ·  RCT Phase 3</a:t>
             </a:r>
             <a:endParaRPr lang="en-US" sz="1000" dirty="0"/>
           </a:p>
@@ -5324,7 +5324,7 @@
                   <a:srgbClr val="888888"/>
                 </a:solidFill>
               </a:rPr>
-              <a:t>X Zhang, H Cai, W Peng. … and Targeted Therapy. 2026</a:t>
+              <a:t>Lim Howard J, Vogel Arndt, Dunne Emma M et al.. Cancer treatment reviews. 2026-09-06 DOI: 10.1016/j.ctrv.2026.103194</a:t>
             </a:r>
             <a:endParaRPr lang="en-US" sz="800" dirty="0"/>
           </a:p>
@@ -5524,7 +5524,7 @@
                   </a:extLst>
                 </a:hlinkClick>
               </a:rPr>
-              <a:t>… (PD-1 inhibitor) plus lenvatinib as conversion therapy followed by sequential surgery (SILENSES) for advanced unresectable hepatocellular carcinoma: a phase II …</a:t>
+              <a:t>Adaptive radiofrequency ablation using an Octopus multipurpose electrode for small hepatocellular carcinoma adjacent to critical structures: a prospective single-center pilot feasibility study.</a:t>
             </a:r>
             <a:endParaRPr lang="en-US" sz="2400" dirty="0"/>
           </a:p>
@@ -5560,7 +5560,7 @@
                   <a:srgbClr val="888888"/>
                 </a:solidFill>
               </a:rPr>
-              <a:t>… and Targeted Therapy  ·  RCT Phase 2</a:t>
+              <a:t>Ultrasonography (Seoul, Korea)  ·  Prospective Study  ·  🌏 Asia</a:t>
             </a:r>
             <a:endParaRPr lang="en-US" sz="1000" dirty="0"/>
           </a:p>
@@ -5639,7 +5639,7 @@
                   <a:srgbClr val="888888"/>
                 </a:solidFill>
               </a:rPr>
-              <a:t>S Lu, W Zhang, J Li. … and Targeted Therapy. 2026</a:t>
+              <a:t>Lee Jeong Min, Kim Jae Hyun, Jo Gyeong Deok et al.. Ultrasonography (Seoul, Korea). 2026-09-03 DOI: 10.14366/usg.26158</a:t>
             </a:r>
             <a:endParaRPr lang="en-US" sz="800" dirty="0"/>
           </a:p>
@@ -5839,7 +5839,7 @@
                   </a:extLst>
                 </a:hlinkClick>
               </a:rPr>
-              <a:t>Defect-Engineered BiO2-X Nanosheets Mediate Sono-Thermomechanical ECM Remodeling for Hepatocellular Carcinoma Immunotherapy.</a:t>
+              <a:t>Clinical predictors of response to atezolizumab/bevacizumab in Child-Pugh B patients with hepatocellular carcinoma.</a:t>
             </a:r>
             <a:endParaRPr lang="en-US" sz="2400" dirty="0"/>
           </a:p>
@@ -5875,7 +5875,7 @@
                   <a:srgbClr val="888888"/>
                 </a:solidFill>
               </a:rPr>
-              <a:t>Advanced science (Weinheim, Baden-Wurttemberg, Germany)  ·  🌏 Asia</a:t>
+              <a:t>JHEP reports : innovation in hepatology  ·  IF 7.8  ·  Retrospective Study  ·  🌏 Asia</a:t>
             </a:r>
             <a:endParaRPr lang="en-US" sz="1000" dirty="0"/>
           </a:p>
@@ -5954,7 +5954,7 @@
                   <a:srgbClr val="888888"/>
                 </a:solidFill>
               </a:rPr>
-              <a:t>Tian Huimin, Zhang Shen, Wu Bolin et al.. Advanced science (Weinheim, Baden-Wurttemberg, Germany). 2026-08-30 DOI: 10.1002/advs.77337</a:t>
+              <a:t>Odent Anne-Victoire, Campani Claudia, Bouattour Mohamed et al.. JHEP reports : innovation in hepatology. 2026-08-27 DOI: 10.1016/j.jhepr.2026.101915</a:t>
             </a:r>
             <a:endParaRPr lang="en-US" sz="800" dirty="0"/>
           </a:p>
@@ -6154,7 +6154,7 @@
                   </a:extLst>
                 </a:hlinkClick>
               </a:rPr>
-              <a:t>Enhanced glucose uptake promotes the survival of hepatocellular carcinoma cells following incomplete radiofrequency ablation.</a:t>
+              <a:t>Spatiotemporal dynamics of the tumor microenvironment in hepatocellular carcinoma during combination immunotherapy.</a:t>
             </a:r>
             <a:endParaRPr lang="en-US" sz="2400" dirty="0"/>
           </a:p>
@@ -6190,7 +6190,7 @@
                   <a:srgbClr val="888888"/>
                 </a:solidFill>
               </a:rPr>
-              <a:t>Molecular &amp; cellular oncology  ·  🌏 Asia</a:t>
+              <a:t>Hepatology communications  ·  IF 5.6  ·  🌏 Asia</a:t>
             </a:r>
             <a:endParaRPr lang="en-US" sz="1000" dirty="0"/>
           </a:p>
@@ -6269,7 +6269,7 @@
                   <a:srgbClr val="888888"/>
                 </a:solidFill>
               </a:rPr>
-              <a:t>Wang Xiaofeng, Li Ting, Peng Chao. Molecular &amp; cellular oncology. 2026-08-29 DOI: 10.1080/23723556.2026.2715876</a:t>
+              <a:t>Iwasaki Hitoshi, Itoh Shinji, Toshida Katsuya et al.. Hepatology communications. 2026-08-07 DOI: 10.1097/HC9.0000000000001014</a:t>
             </a:r>
             <a:endParaRPr lang="en-US" sz="800" dirty="0"/>
           </a:p>

</xml_diff>